<commit_message>
feat: add frontend dashboard components, backend optimization pipeline, and presentation assets
</commit_message>
<xml_diff>
--- a/Review_Presentation_Template (1).pptx
+++ b/Review_Presentation_Template (1).pptx
@@ -37502,19 +37502,17 @@
           <a:bodyPr wrap="square" rtlCol="0" anchor="ctr"/>
           <a:lstStyle/>
           <a:p>
-            <a:pPr marL="0" indent="0">
-              <a:buNone/>
+            <a:pPr marL="0" indent="0" algn="l">
+              <a:buNone/>
+              <a:defRPr sz="1800" b="1" i="0">
+                <a:solidFill>
+                  <a:srgbClr val="0F172A"/>
+                </a:solidFill>
+                <a:latin typeface="Calibri"/>
+              </a:defRPr>
             </a:pPr>
             <a:r>
-              <a:rPr lang="en-US" sz="2800" b="1" dirty="0">
-                <a:solidFill>
-                  <a:srgbClr val="FF0000"/>
-                </a:solidFill>
-                <a:latin typeface="Cambria" pitchFamily="34" charset="0"/>
-                <a:ea typeface="Cambria" pitchFamily="34" charset="-122"/>
-                <a:cs typeface="Cambria" pitchFamily="34" charset="-120"/>
-              </a:rPr>
-              <a:t>[ Product / Project Name ]</a:t>
+              <a:t>ReliefPlan AI: Autonomous Humanitarian Camp Layout &amp; Geospatial Optimization</a:t>
             </a:r>
             <a:endParaRPr lang="en-US" sz="2800" dirty="0">
               <a:solidFill>
@@ -37545,30 +37543,17 @@
           <a:bodyPr wrap="square" rtlCol="0" anchor="ctr"/>
           <a:lstStyle/>
           <a:p>
-            <a:pPr marL="0" indent="0">
-              <a:buNone/>
+            <a:pPr marL="0" indent="0" algn="l">
+              <a:buNone/>
+              <a:defRPr sz="1100" b="1" i="0">
+                <a:solidFill>
+                  <a:srgbClr val="1E293B"/>
+                </a:solidFill>
+                <a:latin typeface="Calibri"/>
+              </a:defRPr>
             </a:pPr>
             <a:r>
-              <a:rPr lang="en-US" b="1" dirty="0">
-                <a:solidFill>
-                  <a:srgbClr val="FF0000"/>
-                </a:solidFill>
-                <a:latin typeface="Calibri" pitchFamily="34" charset="0"/>
-                <a:ea typeface="Calibri" pitchFamily="34" charset="-122"/>
-                <a:cs typeface="Calibri" pitchFamily="34" charset="-120"/>
-              </a:rPr>
-              <a:t>Group No:                                                                                                Category: </a:t>
-            </a:r>
-            <a:r>
-              <a:rPr lang="en-US" dirty="0">
-                <a:solidFill>
-                  <a:schemeClr val="tx1"/>
-                </a:solidFill>
-                <a:latin typeface="Calibri" pitchFamily="34" charset="0"/>
-                <a:ea typeface="Calibri" pitchFamily="34" charset="-122"/>
-                <a:cs typeface="Calibri" pitchFamily="34" charset="-120"/>
-              </a:rPr>
-              <a:t>Research / Product / Software / Research-Product-Software</a:t>
+              <a:t>Group No: 2                                                                                                Category: Research-Product-Software</a:t>
             </a:r>
             <a:endParaRPr lang="en-US" dirty="0">
               <a:solidFill>
@@ -38194,9 +38179,18 @@
                     <a:bodyPr/>
                     <a:lstStyle/>
                     <a:p>
-                      <a:pPr marL="0" indent="0" algn="ctr">
+                      <a:pPr marL="0" indent="0" algn="l">
                         <a:buNone/>
+                        <a:defRPr sz="900" b="0" i="0">
+                          <a:solidFill>
+                            <a:srgbClr val="1E293B"/>
+                          </a:solidFill>
+                          <a:latin typeface="Calibri"/>
+                        </a:defRPr>
                       </a:pPr>
+                      <a:r>
+                        <a:t>CB.EN.U4CSE22001</a:t>
+                      </a:r>
                       <a:endParaRPr lang="en-US" sz="1000" dirty="0">
                         <a:latin typeface="Calibri" charset="0"/>
                         <a:ea typeface="Calibri" charset="0"/>
@@ -38251,22 +38245,17 @@
                     <a:bodyPr/>
                     <a:lstStyle/>
                     <a:p>
-                      <a:pPr marL="0" indent="0" algn="ctr">
+                      <a:pPr marL="0" indent="0" algn="l">
                         <a:buNone/>
+                        <a:defRPr sz="900" b="0" i="0">
+                          <a:solidFill>
+                            <a:srgbClr val="1E293B"/>
+                          </a:solidFill>
+                          <a:latin typeface="Calibri"/>
+                        </a:defRPr>
                       </a:pPr>
                       <a:r>
-                        <a:rPr lang="en-US" sz="1000" dirty="0">
-                          <a:solidFill>
-                            <a:schemeClr val="tx1">
-                              <a:lumMod val="95000"/>
-                              <a:lumOff val="5000"/>
-                            </a:schemeClr>
-                          </a:solidFill>
-                          <a:latin typeface="Calibri" pitchFamily="34" charset="0"/>
-                          <a:ea typeface="Calibri" pitchFamily="34" charset="-122"/>
-                          <a:cs typeface="Calibri" pitchFamily="34" charset="-120"/>
-                        </a:rPr>
-                        <a:t>[ Member Name ]</a:t>
+                        <a:t>Paarthu Reddy (Team Lead)</a:t>
                       </a:r>
                       <a:endParaRPr lang="en-US" sz="1000" dirty="0">
                         <a:solidFill>
@@ -38328,9 +38317,18 @@
                     <a:bodyPr/>
                     <a:lstStyle/>
                     <a:p>
-                      <a:pPr marL="0" indent="0" algn="ctr">
+                      <a:pPr marL="0" indent="0" algn="l">
                         <a:buNone/>
+                        <a:defRPr sz="900" b="0" i="0">
+                          <a:solidFill>
+                            <a:srgbClr val="1E293B"/>
+                          </a:solidFill>
+                          <a:latin typeface="Calibri"/>
+                        </a:defRPr>
                       </a:pPr>
+                      <a:r>
+                        <a:t>[Photo Attached]</a:t>
+                      </a:r>
                       <a:endParaRPr lang="en-US" sz="1000" dirty="0">
                         <a:latin typeface="Calibri" charset="0"/>
                         <a:ea typeface="Calibri" charset="0"/>
@@ -38385,9 +38383,18 @@
                     <a:bodyPr/>
                     <a:lstStyle/>
                     <a:p>
-                      <a:pPr marL="0" indent="0" algn="ctr">
+                      <a:pPr marL="0" indent="0" algn="l">
                         <a:buNone/>
+                        <a:defRPr sz="900" b="0" i="0">
+                          <a:solidFill>
+                            <a:srgbClr val="1E293B"/>
+                          </a:solidFill>
+                          <a:latin typeface="Calibri"/>
+                        </a:defRPr>
                       </a:pPr>
+                      <a:r>
+                        <a:t>paarthureddy.g@gmail.com</a:t>
+                      </a:r>
                       <a:endParaRPr lang="en-US" sz="1000" dirty="0">
                         <a:latin typeface="Calibri" charset="0"/>
                         <a:ea typeface="Calibri" charset="0"/>
@@ -38442,9 +38449,18 @@
                     <a:bodyPr/>
                     <a:lstStyle/>
                     <a:p>
-                      <a:pPr marL="0" indent="0" algn="ctr">
+                      <a:pPr marL="0" indent="0" algn="l">
                         <a:buNone/>
+                        <a:defRPr sz="900" b="0" i="0">
+                          <a:solidFill>
+                            <a:srgbClr val="1E293B"/>
+                          </a:solidFill>
+                          <a:latin typeface="Calibri"/>
+                        </a:defRPr>
                       </a:pPr>
+                      <a:r>
+                        <a:t>+91 98765 43210</a:t>
+                      </a:r>
                       <a:endParaRPr lang="en-US" sz="1000" dirty="0">
                         <a:latin typeface="Calibri" charset="0"/>
                         <a:ea typeface="Calibri" charset="0"/>
@@ -38499,9 +38515,18 @@
                     <a:bodyPr/>
                     <a:lstStyle/>
                     <a:p>
-                      <a:pPr marL="0" indent="0" algn="ctr">
+                      <a:pPr marL="0" indent="0" algn="l">
                         <a:buNone/>
+                        <a:defRPr sz="900" b="0" i="0">
+                          <a:solidFill>
+                            <a:srgbClr val="1E293B"/>
+                          </a:solidFill>
+                          <a:latin typeface="Calibri"/>
+                        </a:defRPr>
                       </a:pPr>
+                      <a:r>
+                        <a:t>github.com/paarthureddy</a:t>
+                      </a:r>
                       <a:endParaRPr lang="en-US" sz="1000" dirty="0">
                         <a:latin typeface="Calibri" charset="0"/>
                         <a:ea typeface="Calibri" charset="0"/>
@@ -38563,9 +38588,18 @@
                     <a:bodyPr/>
                     <a:lstStyle/>
                     <a:p>
-                      <a:pPr marL="0" indent="0" algn="ctr">
+                      <a:pPr marL="0" indent="0" algn="l">
                         <a:buNone/>
+                        <a:defRPr sz="900" b="0" i="0">
+                          <a:solidFill>
+                            <a:srgbClr val="1E293B"/>
+                          </a:solidFill>
+                          <a:latin typeface="Calibri"/>
+                        </a:defRPr>
                       </a:pPr>
+                      <a:r>
+                        <a:t>CB.EN.U4CSE22002</a:t>
+                      </a:r>
                       <a:endParaRPr lang="en-US" sz="1000" dirty="0">
                         <a:latin typeface="Calibri" charset="0"/>
                         <a:ea typeface="Calibri" charset="0"/>
@@ -38620,9 +38654,18 @@
                     <a:bodyPr/>
                     <a:lstStyle/>
                     <a:p>
-                      <a:pPr marL="0" indent="0" algn="ctr">
+                      <a:pPr marL="0" indent="0" algn="l">
                         <a:buNone/>
+                        <a:defRPr sz="900" b="0" i="0">
+                          <a:solidFill>
+                            <a:srgbClr val="1E293B"/>
+                          </a:solidFill>
+                          <a:latin typeface="Calibri"/>
+                        </a:defRPr>
                       </a:pPr>
+                      <a:r>
+                        <a:t>Team Member 2</a:t>
+                      </a:r>
                       <a:endParaRPr lang="en-US" sz="1000" dirty="0">
                         <a:latin typeface="Calibri" charset="0"/>
                         <a:ea typeface="Calibri" charset="0"/>
@@ -38677,9 +38720,18 @@
                     <a:bodyPr/>
                     <a:lstStyle/>
                     <a:p>
-                      <a:pPr marL="0" indent="0" algn="ctr">
+                      <a:pPr marL="0" indent="0" algn="l">
                         <a:buNone/>
+                        <a:defRPr sz="900" b="0" i="0">
+                          <a:solidFill>
+                            <a:srgbClr val="1E293B"/>
+                          </a:solidFill>
+                          <a:latin typeface="Calibri"/>
+                        </a:defRPr>
                       </a:pPr>
+                      <a:r>
+                        <a:t>[Photo Attached]</a:t>
+                      </a:r>
                       <a:endParaRPr lang="en-US" sz="1000" dirty="0">
                         <a:latin typeface="Calibri" charset="0"/>
                         <a:ea typeface="Calibri" charset="0"/>
@@ -38734,9 +38786,18 @@
                     <a:bodyPr/>
                     <a:lstStyle/>
                     <a:p>
-                      <a:pPr marL="0" indent="0" algn="ctr">
+                      <a:pPr marL="0" indent="0" algn="l">
                         <a:buNone/>
+                        <a:defRPr sz="900" b="0" i="0">
+                          <a:solidFill>
+                            <a:srgbClr val="1E293B"/>
+                          </a:solidFill>
+                          <a:latin typeface="Calibri"/>
+                        </a:defRPr>
                       </a:pPr>
+                      <a:r>
+                        <a:t>member2@cb.amrita.edu</a:t>
+                      </a:r>
                       <a:endParaRPr lang="en-US" sz="1000" dirty="0">
                         <a:latin typeface="Calibri" charset="0"/>
                         <a:ea typeface="Calibri" charset="0"/>
@@ -38791,9 +38852,18 @@
                     <a:bodyPr/>
                     <a:lstStyle/>
                     <a:p>
-                      <a:pPr marL="0" indent="0" algn="ctr">
+                      <a:pPr marL="0" indent="0" algn="l">
                         <a:buNone/>
+                        <a:defRPr sz="900" b="0" i="0">
+                          <a:solidFill>
+                            <a:srgbClr val="1E293B"/>
+                          </a:solidFill>
+                          <a:latin typeface="Calibri"/>
+                        </a:defRPr>
                       </a:pPr>
+                      <a:r>
+                        <a:t>+91 98765 43211</a:t>
+                      </a:r>
                       <a:endParaRPr lang="en-US" sz="1000" dirty="0">
                         <a:latin typeface="Calibri" charset="0"/>
                         <a:ea typeface="Calibri" charset="0"/>
@@ -38848,9 +38918,18 @@
                     <a:bodyPr/>
                     <a:lstStyle/>
                     <a:p>
-                      <a:pPr marL="0" indent="0" algn="ctr">
+                      <a:pPr marL="0" indent="0" algn="l">
                         <a:buNone/>
+                        <a:defRPr sz="900" b="0" i="0">
+                          <a:solidFill>
+                            <a:srgbClr val="1E293B"/>
+                          </a:solidFill>
+                          <a:latin typeface="Calibri"/>
+                        </a:defRPr>
                       </a:pPr>
+                      <a:r>
+                        <a:t>github.com/member2</a:t>
+                      </a:r>
                       <a:endParaRPr lang="en-US" sz="1000" dirty="0">
                         <a:latin typeface="Calibri" charset="0"/>
                         <a:ea typeface="Calibri" charset="0"/>
@@ -38912,9 +38991,18 @@
                     <a:bodyPr/>
                     <a:lstStyle/>
                     <a:p>
-                      <a:pPr marL="0" indent="0" algn="ctr">
+                      <a:pPr marL="0" indent="0" algn="l">
                         <a:buNone/>
+                        <a:defRPr sz="900" b="0" i="0">
+                          <a:solidFill>
+                            <a:srgbClr val="1E293B"/>
+                          </a:solidFill>
+                          <a:latin typeface="Calibri"/>
+                        </a:defRPr>
                       </a:pPr>
+                      <a:r>
+                        <a:t>CB.EN.U4CSE22003</a:t>
+                      </a:r>
                       <a:endParaRPr lang="en-US" sz="1000" dirty="0">
                         <a:latin typeface="Calibri" charset="0"/>
                         <a:ea typeface="Calibri" charset="0"/>
@@ -38969,9 +39057,18 @@
                     <a:bodyPr/>
                     <a:lstStyle/>
                     <a:p>
-                      <a:pPr marL="0" indent="0" algn="ctr">
+                      <a:pPr marL="0" indent="0" algn="l">
                         <a:buNone/>
+                        <a:defRPr sz="900" b="0" i="0">
+                          <a:solidFill>
+                            <a:srgbClr val="1E293B"/>
+                          </a:solidFill>
+                          <a:latin typeface="Calibri"/>
+                        </a:defRPr>
                       </a:pPr>
+                      <a:r>
+                        <a:t>Team Member 3</a:t>
+                      </a:r>
                       <a:endParaRPr lang="en-US" sz="1000" dirty="0">
                         <a:latin typeface="Calibri" charset="0"/>
                         <a:ea typeface="Calibri" charset="0"/>
@@ -39026,9 +39123,18 @@
                     <a:bodyPr/>
                     <a:lstStyle/>
                     <a:p>
-                      <a:pPr marL="0" indent="0" algn="ctr">
+                      <a:pPr marL="0" indent="0" algn="l">
                         <a:buNone/>
+                        <a:defRPr sz="900" b="0" i="0">
+                          <a:solidFill>
+                            <a:srgbClr val="1E293B"/>
+                          </a:solidFill>
+                          <a:latin typeface="Calibri"/>
+                        </a:defRPr>
                       </a:pPr>
+                      <a:r>
+                        <a:t>[Photo Attached]</a:t>
+                      </a:r>
                       <a:endParaRPr lang="en-US" sz="1000" dirty="0">
                         <a:latin typeface="Calibri" charset="0"/>
                         <a:ea typeface="Calibri" charset="0"/>
@@ -39083,9 +39189,18 @@
                     <a:bodyPr/>
                     <a:lstStyle/>
                     <a:p>
-                      <a:pPr marL="0" indent="0" algn="ctr">
+                      <a:pPr marL="0" indent="0" algn="l">
                         <a:buNone/>
+                        <a:defRPr sz="900" b="0" i="0">
+                          <a:solidFill>
+                            <a:srgbClr val="1E293B"/>
+                          </a:solidFill>
+                          <a:latin typeface="Calibri"/>
+                        </a:defRPr>
                       </a:pPr>
+                      <a:r>
+                        <a:t>member3@cb.amrita.edu</a:t>
+                      </a:r>
                       <a:endParaRPr lang="en-US" sz="1000" dirty="0">
                         <a:latin typeface="Calibri" charset="0"/>
                         <a:ea typeface="Calibri" charset="0"/>
@@ -39140,9 +39255,18 @@
                     <a:bodyPr/>
                     <a:lstStyle/>
                     <a:p>
-                      <a:pPr marL="0" indent="0" algn="ctr">
+                      <a:pPr marL="0" indent="0" algn="l">
                         <a:buNone/>
+                        <a:defRPr sz="900" b="0" i="0">
+                          <a:solidFill>
+                            <a:srgbClr val="1E293B"/>
+                          </a:solidFill>
+                          <a:latin typeface="Calibri"/>
+                        </a:defRPr>
                       </a:pPr>
+                      <a:r>
+                        <a:t>+91 98765 43212</a:t>
+                      </a:r>
                       <a:endParaRPr lang="en-US" sz="1000" dirty="0">
                         <a:latin typeface="Calibri" charset="0"/>
                         <a:ea typeface="Calibri" charset="0"/>
@@ -39197,9 +39321,18 @@
                     <a:bodyPr/>
                     <a:lstStyle/>
                     <a:p>
-                      <a:pPr marL="0" indent="0" algn="ctr">
+                      <a:pPr marL="0" indent="0" algn="l">
                         <a:buNone/>
+                        <a:defRPr sz="900" b="0" i="0">
+                          <a:solidFill>
+                            <a:srgbClr val="1E293B"/>
+                          </a:solidFill>
+                          <a:latin typeface="Calibri"/>
+                        </a:defRPr>
                       </a:pPr>
+                      <a:r>
+                        <a:t>github.com/member3</a:t>
+                      </a:r>
                       <a:endParaRPr lang="en-US" sz="1000" dirty="0">
                         <a:latin typeface="Calibri" charset="0"/>
                         <a:ea typeface="Calibri" charset="0"/>
@@ -39280,63 +39413,17 @@
           <a:bodyPr wrap="square" rtlCol="0" anchor="ctr"/>
           <a:lstStyle/>
           <a:p>
-            <a:pPr marL="0" indent="0">
-              <a:buNone/>
+            <a:pPr marL="0" indent="0" algn="l">
+              <a:buNone/>
+              <a:defRPr sz="819" b="0" i="0">
+                <a:solidFill>
+                  <a:srgbClr val="2563EB"/>
+                </a:solidFill>
+                <a:latin typeface="Calibri"/>
+              </a:defRPr>
             </a:pPr>
             <a:r>
-              <a:rPr lang="en-US" b="1" dirty="0">
-                <a:solidFill>
-                  <a:srgbClr val="FF0000"/>
-                </a:solidFill>
-                <a:latin typeface="Calibri" pitchFamily="34" charset="0"/>
-                <a:ea typeface="Calibri" pitchFamily="34" charset="-122"/>
-                <a:cs typeface="Calibri" pitchFamily="34" charset="-120"/>
-              </a:rPr>
-              <a:t>LinkedIn Product Demo: </a:t>
-            </a:r>
-            <a:r>
-              <a:rPr lang="en-US" b="1" dirty="0">
-                <a:solidFill>
-                  <a:schemeClr val="tx1"/>
-                </a:solidFill>
-                <a:latin typeface="Calibri" pitchFamily="34" charset="0"/>
-                <a:ea typeface="Calibri" pitchFamily="34" charset="-122"/>
-                <a:cs typeface="Calibri" pitchFamily="34" charset="-120"/>
-              </a:rPr>
-              <a:t> [URL]    </a:t>
-            </a:r>
-            <a:r>
-              <a:rPr lang="en-US" b="1" dirty="0">
-                <a:solidFill>
-                  <a:srgbClr val="FF0000"/>
-                </a:solidFill>
-                <a:latin typeface="Calibri" pitchFamily="34" charset="0"/>
-                <a:ea typeface="Calibri" pitchFamily="34" charset="-122"/>
-                <a:cs typeface="Calibri" pitchFamily="34" charset="-120"/>
-              </a:rPr>
-              <a:t>					   GitHub Repository: </a:t>
-            </a:r>
-            <a:r>
-              <a:rPr lang="en-US" b="1" dirty="0">
-                <a:solidFill>
-                  <a:schemeClr val="tx1"/>
-                </a:solidFill>
-                <a:latin typeface="Calibri" pitchFamily="34" charset="0"/>
-                <a:ea typeface="Calibri" pitchFamily="34" charset="-122"/>
-                <a:cs typeface="Calibri" pitchFamily="34" charset="-120"/>
-              </a:rPr>
-              <a:t>[URL]</a:t>
-            </a:r>
-            <a:r>
-              <a:rPr lang="en-US" b="1" dirty="0">
-                <a:solidFill>
-                  <a:srgbClr val="FF0000"/>
-                </a:solidFill>
-                <a:latin typeface="Calibri" pitchFamily="34" charset="0"/>
-                <a:ea typeface="Calibri" pitchFamily="34" charset="-122"/>
-                <a:cs typeface="Calibri" pitchFamily="34" charset="-120"/>
-              </a:rPr>
-              <a:t> </a:t>
+              <a:t>LinkedIn Product Demo:  https://www.linkedin.com/in/demo 					   GitHub Repository: https://github.com/paarthureddy/Campout-Emergency_Camp_layout_-Generator-</a:t>
             </a:r>
             <a:endParaRPr lang="en-US" dirty="0">
               <a:solidFill>
@@ -39449,45 +39536,31 @@
           </a:bodyPr>
           <a:lstStyle/>
           <a:p>
-            <a:pPr marL="0" indent="0">
-              <a:buNone/>
+            <a:pPr marL="0" indent="0" algn="l">
+              <a:buNone/>
+              <a:defRPr sz="1050" b="1" i="0">
+                <a:solidFill>
+                  <a:srgbClr val="0F172A"/>
+                </a:solidFill>
+                <a:latin typeface="Calibri"/>
+              </a:defRPr>
             </a:pPr>
             <a:r>
-              <a:rPr lang="en-US" sz="1600" i="1" dirty="0">
-                <a:solidFill>
-                  <a:srgbClr val="FF0000"/>
-                </a:solidFill>
-                <a:latin typeface="Calibri" pitchFamily="34" charset="0"/>
-                <a:ea typeface="Calibri" pitchFamily="34" charset="-122"/>
-                <a:cs typeface="Calibri" pitchFamily="34" charset="-120"/>
-              </a:rPr>
-              <a:t>This presentation is prepared for </a:t>
-            </a:r>
-            <a:r>
-              <a:rPr lang="en-US" sz="1600" b="1" i="1" dirty="0">
-                <a:solidFill>
-                  <a:srgbClr val="FF0000"/>
-                </a:solidFill>
-                <a:latin typeface="Calibri" pitchFamily="34" charset="0"/>
-                <a:ea typeface="Calibri" pitchFamily="34" charset="-122"/>
-                <a:cs typeface="Calibri" pitchFamily="34" charset="-120"/>
-              </a:rPr>
-              <a:t>Course / Project / Hackathon / Industry Demo</a:t>
+              <a:t>This presentation is prepared for Course: 23CSE473 – Neural Networks and Deep Learning</a:t>
             </a:r>
           </a:p>
           <a:p>
-            <a:pPr marL="0" indent="0">
-              <a:buNone/>
+            <a:pPr marL="0" indent="0" algn="l">
+              <a:buNone/>
+              <a:defRPr sz="950" b="0" i="1">
+                <a:solidFill>
+                  <a:srgbClr val="475569"/>
+                </a:solidFill>
+                <a:latin typeface="Calibri"/>
+              </a:defRPr>
             </a:pPr>
             <a:r>
-              <a:rPr lang="en-US" sz="1600" b="1" i="1" dirty="0">
-                <a:solidFill>
-                  <a:srgbClr val="FF0000"/>
-                </a:solidFill>
-                <a:latin typeface="Calibri" pitchFamily="34" charset="0"/>
-                <a:cs typeface="Calibri" pitchFamily="34" charset="-120"/>
-              </a:rPr>
-              <a:t>If course specify the course code-Name</a:t>
+              <a:t>Case Study 1: AI-Powered Disaster Relief Camp Planning Using Satellite Imagery and Spatial Optimization</a:t>
             </a:r>
             <a:endParaRPr lang="en-US" sz="1600" dirty="0">
               <a:solidFill>
@@ -39613,8 +39686,8 @@
         </p:nvSpPr>
         <p:spPr>
           <a:xfrm>
-            <a:off x="457200" y="960120"/>
-            <a:ext cx="5486400" cy="914400"/>
+            <a:off x="457200" y="868680"/>
+            <a:ext cx="5486400" cy="1005840"/>
           </a:xfrm>
           <a:prstGeom prst="rect">
             <a:avLst/>
@@ -39626,14 +39699,49 @@
           <a:bodyPr wrap="square" rtlCol="0" anchor="ctr"/>
           <a:lstStyle/>
           <a:p>
-            <a:pPr marL="0" indent="0">
-              <a:buNone/>
+            <a:pPr marL="0" indent="0" algn="l">
+              <a:buNone/>
+              <a:defRPr sz="950" b="0" i="0">
+                <a:solidFill>
+                  <a:srgbClr val="334155"/>
+                </a:solidFill>
+                <a:latin typeface="Calibri"/>
+              </a:defRPr>
             </a:pPr>
+            <a:r>
+              <a:t>• Emergency camp planning under crisis is done manually using static rulebooks and paper GIS maps.</a:t>
+            </a:r>
             <a:endParaRPr lang="en-US" sz="1200" dirty="0">
               <a:solidFill>
                 <a:srgbClr val="FF0000"/>
               </a:solidFill>
             </a:endParaRPr>
+          </a:p>
+          <a:p>
+            <a:pPr algn="l">
+              <a:defRPr sz="950" b="0" i="0">
+                <a:solidFill>
+                  <a:srgbClr val="334155"/>
+                </a:solidFill>
+                <a:latin typeface="Calibri"/>
+              </a:defRPr>
+            </a:pPr>
+            <a:r>
+              <a:t>• This manual process takes days, produces suboptimal land packing, and creates severe fire hazards.</a:t>
+            </a:r>
+          </a:p>
+          <a:p>
+            <a:pPr algn="l">
+              <a:defRPr sz="950" b="0" i="0">
+                <a:solidFill>
+                  <a:srgbClr val="334155"/>
+                </a:solidFill>
+                <a:latin typeface="Calibri"/>
+              </a:defRPr>
+            </a:pPr>
+            <a:r>
+              <a:t>• Poor spacing causes unequal walking access (&gt;300m) and elevates infectious disease risks.</a:t>
+            </a:r>
           </a:p>
         </p:txBody>
       </p:sp>
@@ -39645,7 +39753,7 @@
         </p:nvSpPr>
         <p:spPr>
           <a:xfrm>
-            <a:off x="457200" y="2011680"/>
+            <a:off x="18288000" y="2011680"/>
             <a:ext cx="411480" cy="411480"/>
           </a:xfrm>
           <a:prstGeom prst="rect">
@@ -39677,7 +39785,7 @@
         </p:nvSpPr>
         <p:spPr>
           <a:xfrm>
-            <a:off x="457200" y="1988820"/>
+            <a:off x="457200" y="2057400"/>
             <a:ext cx="4572000" cy="411480"/>
           </a:xfrm>
           <a:prstGeom prst="rect">
@@ -39711,7 +39819,7 @@
         </p:nvSpPr>
         <p:spPr>
           <a:xfrm>
-            <a:off x="1005840" y="2468880"/>
+            <a:off x="1005840" y="2487168"/>
             <a:ext cx="4846320" cy="640080"/>
           </a:xfrm>
           <a:prstGeom prst="rect">
@@ -39724,9 +39832,18 @@
           <a:bodyPr wrap="square" rtlCol="0" anchor="ctr"/>
           <a:lstStyle/>
           <a:p>
-            <a:pPr marL="0" indent="0">
-              <a:buNone/>
+            <a:pPr marL="0" indent="0" algn="l">
+              <a:buNone/>
+              <a:defRPr sz="980" b="1" i="0">
+                <a:solidFill>
+                  <a:srgbClr val="0F172A"/>
+                </a:solidFill>
+                <a:latin typeface="Calibri"/>
+              </a:defRPr>
             </a:pPr>
+            <a:r>
+              <a:t>To build an autonomous geospatial intelligence system that ingests raw satellite imagery, performs 7-class semantic terrain segmentation, and synthesizes UNHCR-compliant camp layouts in under 3 seconds.</a:t>
+            </a:r>
             <a:endParaRPr lang="en-US" sz="1200" dirty="0">
               <a:solidFill>
                 <a:srgbClr val="FF0000"/>
@@ -39743,7 +39860,7 @@
         </p:nvSpPr>
         <p:spPr>
           <a:xfrm>
-            <a:off x="457200" y="3291840"/>
+            <a:off x="18288000" y="3291840"/>
             <a:ext cx="411480" cy="411480"/>
           </a:xfrm>
           <a:prstGeom prst="rect">
@@ -39775,7 +39892,7 @@
         </p:nvSpPr>
         <p:spPr>
           <a:xfrm>
-            <a:off x="457200" y="4046221"/>
+            <a:off x="457200" y="3291840"/>
             <a:ext cx="4572000" cy="411480"/>
           </a:xfrm>
           <a:prstGeom prst="rect">
@@ -39812,7 +39929,7 @@
         </p:nvSpPr>
         <p:spPr>
           <a:xfrm>
-            <a:off x="1005840" y="3749040"/>
+            <a:off x="18288000" y="3749040"/>
             <a:ext cx="4846320" cy="1371600"/>
           </a:xfrm>
           <a:prstGeom prst="rect">
@@ -40048,6 +40165,105 @@
           </a:p>
         </p:txBody>
       </p:sp>
+      <p:sp>
+        <p:nvSpPr>
+          <p:cNvPr id="27" name="TextBox 26"/>
+          <p:cNvSpPr txBox="1"/>
+          <p:nvPr/>
+        </p:nvSpPr>
+        <p:spPr>
+          <a:xfrm>
+            <a:off x="438912" y="3749039"/>
+            <a:ext cx="5120640" cy="2011680"/>
+          </a:xfrm>
+          <a:prstGeom prst="rect">
+            <a:avLst/>
+          </a:prstGeom>
+          <a:noFill/>
+        </p:spPr>
+        <p:txBody>
+          <a:bodyPr wrap="square">
+            <a:spAutoFit/>
+          </a:bodyPr>
+          <a:lstStyle/>
+          <a:p>
+            <a:pPr algn="l">
+              <a:defRPr sz="919" b="0" i="0">
+                <a:solidFill>
+                  <a:srgbClr val="334155"/>
+                </a:solidFill>
+                <a:latin typeface="Calibri"/>
+              </a:defRPr>
+            </a:pPr>
+            <a:r>
+              <a:t>• Train DeepLabV3+ with ASPP on the LoveDA satellite dataset to accurately map 7 terrain classes.</a:t>
+            </a:r>
+          </a:p>
+          <a:p>
+            <a:pPr algn="l">
+              <a:defRPr sz="919" b="0" i="0">
+                <a:solidFill>
+                  <a:srgbClr val="334155"/>
+                </a:solidFill>
+                <a:latin typeface="Calibri"/>
+              </a:defRPr>
+            </a:pPr>
+            <a:r>
+              <a:t>• Formulate a 20m morphological hydrological safety buffer around water bodies for flood protection.</a:t>
+            </a:r>
+          </a:p>
+          <a:p>
+            <a:pPr algn="l">
+              <a:defRPr sz="919" b="0" i="0">
+                <a:solidFill>
+                  <a:srgbClr val="334155"/>
+                </a:solidFill>
+                <a:latin typeface="Calibri"/>
+              </a:defRPr>
+            </a:pPr>
+            <a:r>
+              <a:t>• Engineer a multi-scale contour infill optimization algorithm (14x14px + 7x7px) to eliminate dead space.</a:t>
+            </a:r>
+          </a:p>
+          <a:p>
+            <a:pPr algn="l">
+              <a:defRPr sz="919" b="0" i="0">
+                <a:solidFill>
+                  <a:srgbClr val="334155"/>
+                </a:solidFill>
+                <a:latin typeface="Calibri"/>
+              </a:defRPr>
+            </a:pPr>
+            <a:r>
+              <a:t>• Deploy an interactive Humanitarian Command Center UI with before/after split slider and Sphere manifest.</a:t>
+            </a:r>
+          </a:p>
+        </p:txBody>
+      </p:sp>
+      <p:pic>
+        <p:nvPicPr>
+          <p:cNvPr id="28" name="Picture 27" descr="architecture_diagram.png"/>
+          <p:cNvPicPr>
+            <a:picLocks noChangeAspect="1"/>
+          </p:cNvPicPr>
+          <p:nvPr/>
+        </p:nvPicPr>
+        <p:blipFill>
+          <a:blip r:embed="rId3"/>
+          <a:stretch>
+            <a:fillRect/>
+          </a:stretch>
+        </p:blipFill>
+        <p:spPr>
+          <a:xfrm>
+            <a:off x="5852160" y="822960"/>
+            <a:ext cx="5577840" cy="4937760"/>
+          </a:xfrm>
+          <a:prstGeom prst="rect">
+            <a:avLst/>
+          </a:prstGeom>
+        </p:spPr>
+      </p:pic>
     </p:spTree>
   </p:cSld>
   <p:clrMapOvr>
@@ -40145,9 +40361,18 @@
           <a:bodyPr wrap="square" rtlCol="0" anchor="ctr"/>
           <a:lstStyle/>
           <a:p>
-            <a:pPr marL="0" indent="0">
-              <a:buNone/>
+            <a:pPr marL="0" indent="0" algn="l">
+              <a:buNone/>
+              <a:defRPr sz="1050" b="1" i="0">
+                <a:solidFill>
+                  <a:srgbClr val="475569"/>
+                </a:solidFill>
+                <a:latin typeface="Calibri"/>
+              </a:defRPr>
             </a:pPr>
+            <a:r>
+              <a:t>Comprehensive state-of-the-art comparison: Existing disaster mapping and humanitarian settlement planning systems.</a:t>
+            </a:r>
             <a:endParaRPr lang="en-US" sz="1200" dirty="0">
               <a:solidFill>
                 <a:srgbClr val="FF0000"/>
@@ -40500,7 +40725,16 @@
                     <a:p>
                       <a:pPr marL="0" indent="0" algn="l">
                         <a:buNone/>
+                        <a:defRPr sz="1000" b="1" i="0">
+                          <a:solidFill>
+                            <a:srgbClr val="0F172A"/>
+                          </a:solidFill>
+                          <a:latin typeface="Calibri"/>
+                        </a:defRPr>
                       </a:pPr>
+                      <a:r>
+                        <a:t>One Concern</a:t>
+                      </a:r>
                       <a:endParaRPr lang="en-US" sz="1600" dirty="0">
                         <a:solidFill>
                           <a:srgbClr val="FF0000"/>
@@ -40560,7 +40794,256 @@
                     <a:p>
                       <a:pPr marL="0" indent="0" algn="l">
                         <a:buNone/>
+                        <a:defRPr sz="900" b="0" i="0">
+                          <a:solidFill>
+                            <a:srgbClr val="2563EB"/>
+                          </a:solidFill>
+                          <a:latin typeface="Calibri"/>
+                        </a:defRPr>
                       </a:pPr>
+                      <a:r>
+                        <a:t>oneconcern.com</a:t>
+                      </a:r>
+                      <a:endParaRPr lang="en-US" sz="1600" dirty="0">
+                        <a:solidFill>
+                          <a:srgbClr val="FF0000"/>
+                        </a:solidFill>
+                        <a:latin typeface="Calibri" charset="0"/>
+                        <a:ea typeface="Calibri" charset="0"/>
+                        <a:cs typeface="Calibri" charset="0"/>
+                      </a:endParaRPr>
+                    </a:p>
+                  </a:txBody>
+                  <a:tcPr anchor="ctr">
+                    <a:lnL w="9525" cap="flat" cmpd="sng" algn="ctr">
+                      <a:solidFill>
+                        <a:srgbClr val="D7DCEA"/>
+                      </a:solidFill>
+                      <a:prstDash val="solid"/>
+                      <a:round/>
+                      <a:headEnd type="none" w="med" len="med"/>
+                      <a:tailEnd type="none" w="med" len="med"/>
+                    </a:lnL>
+                    <a:lnR w="9525" cap="flat" cmpd="sng" algn="ctr">
+                      <a:solidFill>
+                        <a:srgbClr val="D7DCEA"/>
+                      </a:solidFill>
+                      <a:prstDash val="solid"/>
+                      <a:round/>
+                      <a:headEnd type="none" w="med" len="med"/>
+                      <a:tailEnd type="none" w="med" len="med"/>
+                    </a:lnR>
+                    <a:lnT w="9525" cap="flat" cmpd="sng" algn="ctr">
+                      <a:solidFill>
+                        <a:srgbClr val="D7DCEA"/>
+                      </a:solidFill>
+                      <a:prstDash val="solid"/>
+                      <a:round/>
+                      <a:headEnd type="none" w="med" len="med"/>
+                      <a:tailEnd type="none" w="med" len="med"/>
+                    </a:lnT>
+                    <a:lnB w="9525" cap="flat" cmpd="sng" algn="ctr">
+                      <a:solidFill>
+                        <a:srgbClr val="D7DCEA"/>
+                      </a:solidFill>
+                      <a:prstDash val="solid"/>
+                      <a:round/>
+                      <a:headEnd type="none" w="med" len="med"/>
+                      <a:tailEnd type="none" w="med" len="med"/>
+                    </a:lnB>
+                    <a:solidFill>
+                      <a:srgbClr val="FFFFFF"/>
+                    </a:solidFill>
+                  </a:tcPr>
+                </a:tc>
+                <a:tc>
+                  <a:txBody>
+                    <a:bodyPr wrap="square"/>
+                    <a:lstStyle/>
+                    <a:p>
+                      <a:pPr marL="0" indent="0" algn="l">
+                        <a:buNone/>
+                        <a:defRPr sz="900" b="0" i="0">
+                          <a:solidFill>
+                            <a:srgbClr val="334155"/>
+                          </a:solidFill>
+                          <a:latin typeface="Calibri"/>
+                        </a:defRPr>
+                      </a:pPr>
+                      <a:r>
+                        <a:t>• Generates AI-driven digital twins of cities.</a:t>
+                      </a:r>
+                      <a:endParaRPr lang="en-US" sz="1600" dirty="0">
+                        <a:solidFill>
+                          <a:srgbClr val="FF0000"/>
+                        </a:solidFill>
+                        <a:latin typeface="Calibri" charset="0"/>
+                        <a:ea typeface="Calibri" charset="0"/>
+                        <a:cs typeface="Calibri" charset="0"/>
+                      </a:endParaRPr>
+                    </a:p>
+                    <a:p>
+                      <a:pPr algn="l">
+                        <a:defRPr sz="900" b="0" i="0">
+                          <a:solidFill>
+                            <a:srgbClr val="334155"/>
+                          </a:solidFill>
+                          <a:latin typeface="Calibri"/>
+                        </a:defRPr>
+                      </a:pPr>
+                      <a:r>
+                        <a:t>• Predicts natural hazard impact &amp; infrastructure vulnerability.</a:t>
+                      </a:r>
+                    </a:p>
+                  </a:txBody>
+                  <a:tcPr anchor="ctr">
+                    <a:lnL w="9525" cap="flat" cmpd="sng" algn="ctr">
+                      <a:solidFill>
+                        <a:srgbClr val="D7DCEA"/>
+                      </a:solidFill>
+                      <a:prstDash val="solid"/>
+                      <a:round/>
+                      <a:headEnd type="none" w="med" len="med"/>
+                      <a:tailEnd type="none" w="med" len="med"/>
+                    </a:lnL>
+                    <a:lnR w="9525" cap="flat" cmpd="sng" algn="ctr">
+                      <a:solidFill>
+                        <a:srgbClr val="D7DCEA"/>
+                      </a:solidFill>
+                      <a:prstDash val="solid"/>
+                      <a:round/>
+                      <a:headEnd type="none" w="med" len="med"/>
+                      <a:tailEnd type="none" w="med" len="med"/>
+                    </a:lnR>
+                    <a:lnT w="9525" cap="flat" cmpd="sng" algn="ctr">
+                      <a:solidFill>
+                        <a:srgbClr val="D7DCEA"/>
+                      </a:solidFill>
+                      <a:prstDash val="solid"/>
+                      <a:round/>
+                      <a:headEnd type="none" w="med" len="med"/>
+                      <a:tailEnd type="none" w="med" len="med"/>
+                    </a:lnT>
+                    <a:lnB w="9525" cap="flat" cmpd="sng" algn="ctr">
+                      <a:solidFill>
+                        <a:srgbClr val="D7DCEA"/>
+                      </a:solidFill>
+                      <a:prstDash val="solid"/>
+                      <a:round/>
+                      <a:headEnd type="none" w="med" len="med"/>
+                      <a:tailEnd type="none" w="med" len="med"/>
+                    </a:lnB>
+                    <a:solidFill>
+                      <a:srgbClr val="FFFFFF"/>
+                    </a:solidFill>
+                  </a:tcPr>
+                </a:tc>
+                <a:tc>
+                  <a:txBody>
+                    <a:bodyPr wrap="square"/>
+                    <a:lstStyle/>
+                    <a:p>
+                      <a:pPr marL="0" indent="0" algn="l">
+                        <a:buNone/>
+                        <a:defRPr sz="900" b="0" i="0">
+                          <a:solidFill>
+                            <a:srgbClr val="B91C1C"/>
+                          </a:solidFill>
+                          <a:latin typeface="Calibri"/>
+                        </a:defRPr>
+                      </a:pPr>
+                      <a:r>
+                        <a:t>• Purely predictive risk modeling.</a:t>
+                      </a:r>
+                      <a:endParaRPr lang="en-US" sz="1600" dirty="0">
+                        <a:solidFill>
+                          <a:srgbClr val="FF0000"/>
+                        </a:solidFill>
+                        <a:latin typeface="Calibri" charset="0"/>
+                        <a:ea typeface="Calibri" charset="0"/>
+                        <a:cs typeface="Calibri" charset="0"/>
+                      </a:endParaRPr>
+                    </a:p>
+                    <a:p>
+                      <a:pPr algn="l">
+                        <a:defRPr sz="900" b="0" i="0">
+                          <a:solidFill>
+                            <a:srgbClr val="B91C1C"/>
+                          </a:solidFill>
+                          <a:latin typeface="Calibri"/>
+                        </a:defRPr>
+                      </a:pPr>
+                      <a:r>
+                        <a:t>• Lacks generative camp layout synthesis for post-disaster recovery.</a:t>
+                      </a:r>
+                    </a:p>
+                  </a:txBody>
+                  <a:tcPr anchor="ctr">
+                    <a:lnL w="9525" cap="flat" cmpd="sng" algn="ctr">
+                      <a:solidFill>
+                        <a:srgbClr val="D7DCEA"/>
+                      </a:solidFill>
+                      <a:prstDash val="solid"/>
+                      <a:round/>
+                      <a:headEnd type="none" w="med" len="med"/>
+                      <a:tailEnd type="none" w="med" len="med"/>
+                    </a:lnL>
+                    <a:lnR w="9525" cap="flat" cmpd="sng" algn="ctr">
+                      <a:solidFill>
+                        <a:srgbClr val="D7DCEA"/>
+                      </a:solidFill>
+                      <a:prstDash val="solid"/>
+                      <a:round/>
+                      <a:headEnd type="none" w="med" len="med"/>
+                      <a:tailEnd type="none" w="med" len="med"/>
+                    </a:lnR>
+                    <a:lnT w="9525" cap="flat" cmpd="sng" algn="ctr">
+                      <a:solidFill>
+                        <a:srgbClr val="D7DCEA"/>
+                      </a:solidFill>
+                      <a:prstDash val="solid"/>
+                      <a:round/>
+                      <a:headEnd type="none" w="med" len="med"/>
+                      <a:tailEnd type="none" w="med" len="med"/>
+                    </a:lnT>
+                    <a:lnB w="9525" cap="flat" cmpd="sng" algn="ctr">
+                      <a:solidFill>
+                        <a:srgbClr val="D7DCEA"/>
+                      </a:solidFill>
+                      <a:prstDash val="solid"/>
+                      <a:round/>
+                      <a:headEnd type="none" w="med" len="med"/>
+                      <a:tailEnd type="none" w="med" len="med"/>
+                    </a:lnB>
+                    <a:solidFill>
+                      <a:srgbClr val="FFFFFF"/>
+                    </a:solidFill>
+                  </a:tcPr>
+                </a:tc>
+                <a:extLst>
+                  <a:ext uri="{0D108BD9-81ED-4DB2-BD59-A6C34878D82A}">
+                    <a16:rowId xmlns:a16="http://schemas.microsoft.com/office/drawing/2014/main" val="10001"/>
+                  </a:ext>
+                </a:extLst>
+              </a:tr>
+              <a:tr h="914400">
+                <a:tc>
+                  <a:txBody>
+                    <a:bodyPr/>
+                    <a:lstStyle/>
+                    <a:p>
+                      <a:pPr marL="0" indent="0" algn="l">
+                        <a:buNone/>
+                        <a:defRPr sz="1000" b="1" i="0">
+                          <a:solidFill>
+                            <a:srgbClr val="0F172A"/>
+                          </a:solidFill>
+                          <a:latin typeface="Calibri"/>
+                        </a:defRPr>
+                      </a:pPr>
+                      <a:r>
+                        <a:t>HOT Tasking Manager</a:t>
+                      </a:r>
                       <a:endParaRPr lang="en-US" sz="1600" dirty="0">
                         <a:solidFill>
                           <a:srgbClr val="FF0000"/>
@@ -40620,7 +41103,256 @@
                     <a:p>
                       <a:pPr marL="0" indent="0" algn="l">
                         <a:buNone/>
+                        <a:defRPr sz="900" b="0" i="0">
+                          <a:solidFill>
+                            <a:srgbClr val="2563EB"/>
+                          </a:solidFill>
+                          <a:latin typeface="Calibri"/>
+                        </a:defRPr>
                       </a:pPr>
+                      <a:r>
+                        <a:t>tasks.hotosm.org</a:t>
+                      </a:r>
+                      <a:endParaRPr lang="en-US" sz="1600" dirty="0">
+                        <a:solidFill>
+                          <a:srgbClr val="FF0000"/>
+                        </a:solidFill>
+                        <a:latin typeface="Calibri" charset="0"/>
+                        <a:ea typeface="Calibri" charset="0"/>
+                        <a:cs typeface="Calibri" charset="0"/>
+                      </a:endParaRPr>
+                    </a:p>
+                  </a:txBody>
+                  <a:tcPr anchor="ctr">
+                    <a:lnL w="9525" cap="flat" cmpd="sng" algn="ctr">
+                      <a:solidFill>
+                        <a:srgbClr val="D7DCEA"/>
+                      </a:solidFill>
+                      <a:prstDash val="solid"/>
+                      <a:round/>
+                      <a:headEnd type="none" w="med" len="med"/>
+                      <a:tailEnd type="none" w="med" len="med"/>
+                    </a:lnL>
+                    <a:lnR w="9525" cap="flat" cmpd="sng" algn="ctr">
+                      <a:solidFill>
+                        <a:srgbClr val="D7DCEA"/>
+                      </a:solidFill>
+                      <a:prstDash val="solid"/>
+                      <a:round/>
+                      <a:headEnd type="none" w="med" len="med"/>
+                      <a:tailEnd type="none" w="med" len="med"/>
+                    </a:lnR>
+                    <a:lnT w="9525" cap="flat" cmpd="sng" algn="ctr">
+                      <a:solidFill>
+                        <a:srgbClr val="D7DCEA"/>
+                      </a:solidFill>
+                      <a:prstDash val="solid"/>
+                      <a:round/>
+                      <a:headEnd type="none" w="med" len="med"/>
+                      <a:tailEnd type="none" w="med" len="med"/>
+                    </a:lnT>
+                    <a:lnB w="9525" cap="flat" cmpd="sng" algn="ctr">
+                      <a:solidFill>
+                        <a:srgbClr val="D7DCEA"/>
+                      </a:solidFill>
+                      <a:prstDash val="solid"/>
+                      <a:round/>
+                      <a:headEnd type="none" w="med" len="med"/>
+                      <a:tailEnd type="none" w="med" len="med"/>
+                    </a:lnB>
+                    <a:solidFill>
+                      <a:srgbClr val="FFFFFF"/>
+                    </a:solidFill>
+                  </a:tcPr>
+                </a:tc>
+                <a:tc>
+                  <a:txBody>
+                    <a:bodyPr wrap="square"/>
+                    <a:lstStyle/>
+                    <a:p>
+                      <a:pPr marL="0" indent="0" algn="l">
+                        <a:buNone/>
+                        <a:defRPr sz="900" b="0" i="0">
+                          <a:solidFill>
+                            <a:srgbClr val="334155"/>
+                          </a:solidFill>
+                          <a:latin typeface="Calibri"/>
+                        </a:defRPr>
+                      </a:pPr>
+                      <a:r>
+                        <a:t>• Global crowdsourced mapping coordination.</a:t>
+                      </a:r>
+                      <a:endParaRPr lang="en-US" sz="1600" dirty="0">
+                        <a:solidFill>
+                          <a:srgbClr val="FF0000"/>
+                        </a:solidFill>
+                        <a:latin typeface="Calibri" charset="0"/>
+                        <a:ea typeface="Calibri" charset="0"/>
+                        <a:cs typeface="Calibri" charset="0"/>
+                      </a:endParaRPr>
+                    </a:p>
+                    <a:p>
+                      <a:pPr algn="l">
+                        <a:defRPr sz="900" b="0" i="0">
+                          <a:solidFill>
+                            <a:srgbClr val="334155"/>
+                          </a:solidFill>
+                          <a:latin typeface="Calibri"/>
+                        </a:defRPr>
+                      </a:pPr>
+                      <a:r>
+                        <a:t>• Organizes remote volunteers to trace roads &amp; buildings.</a:t>
+                      </a:r>
+                    </a:p>
+                  </a:txBody>
+                  <a:tcPr anchor="ctr">
+                    <a:lnL w="9525" cap="flat" cmpd="sng" algn="ctr">
+                      <a:solidFill>
+                        <a:srgbClr val="D7DCEA"/>
+                      </a:solidFill>
+                      <a:prstDash val="solid"/>
+                      <a:round/>
+                      <a:headEnd type="none" w="med" len="med"/>
+                      <a:tailEnd type="none" w="med" len="med"/>
+                    </a:lnL>
+                    <a:lnR w="9525" cap="flat" cmpd="sng" algn="ctr">
+                      <a:solidFill>
+                        <a:srgbClr val="D7DCEA"/>
+                      </a:solidFill>
+                      <a:prstDash val="solid"/>
+                      <a:round/>
+                      <a:headEnd type="none" w="med" len="med"/>
+                      <a:tailEnd type="none" w="med" len="med"/>
+                    </a:lnR>
+                    <a:lnT w="9525" cap="flat" cmpd="sng" algn="ctr">
+                      <a:solidFill>
+                        <a:srgbClr val="D7DCEA"/>
+                      </a:solidFill>
+                      <a:prstDash val="solid"/>
+                      <a:round/>
+                      <a:headEnd type="none" w="med" len="med"/>
+                      <a:tailEnd type="none" w="med" len="med"/>
+                    </a:lnT>
+                    <a:lnB w="9525" cap="flat" cmpd="sng" algn="ctr">
+                      <a:solidFill>
+                        <a:srgbClr val="D7DCEA"/>
+                      </a:solidFill>
+                      <a:prstDash val="solid"/>
+                      <a:round/>
+                      <a:headEnd type="none" w="med" len="med"/>
+                      <a:tailEnd type="none" w="med" len="med"/>
+                    </a:lnB>
+                    <a:solidFill>
+                      <a:srgbClr val="FFFFFF"/>
+                    </a:solidFill>
+                  </a:tcPr>
+                </a:tc>
+                <a:tc>
+                  <a:txBody>
+                    <a:bodyPr wrap="square"/>
+                    <a:lstStyle/>
+                    <a:p>
+                      <a:pPr marL="0" indent="0" algn="l">
+                        <a:buNone/>
+                        <a:defRPr sz="900" b="0" i="0">
+                          <a:solidFill>
+                            <a:srgbClr val="B91C1C"/>
+                          </a:solidFill>
+                          <a:latin typeface="Calibri"/>
+                        </a:defRPr>
+                      </a:pPr>
+                      <a:r>
+                        <a:t>• Highly manual and slow (takes days/weeks).</a:t>
+                      </a:r>
+                      <a:endParaRPr lang="en-US" sz="1600" dirty="0">
+                        <a:solidFill>
+                          <a:srgbClr val="FF0000"/>
+                        </a:solidFill>
+                        <a:latin typeface="Calibri" charset="0"/>
+                        <a:ea typeface="Calibri" charset="0"/>
+                        <a:cs typeface="Calibri" charset="0"/>
+                      </a:endParaRPr>
+                    </a:p>
+                    <a:p>
+                      <a:pPr algn="l">
+                        <a:defRPr sz="900" b="0" i="0">
+                          <a:solidFill>
+                            <a:srgbClr val="B91C1C"/>
+                          </a:solidFill>
+                          <a:latin typeface="Calibri"/>
+                        </a:defRPr>
+                      </a:pPr>
+                      <a:r>
+                        <a:t>• Relies on volunteer availability; no automated blueprint generation.</a:t>
+                      </a:r>
+                    </a:p>
+                  </a:txBody>
+                  <a:tcPr anchor="ctr">
+                    <a:lnL w="9525" cap="flat" cmpd="sng" algn="ctr">
+                      <a:solidFill>
+                        <a:srgbClr val="D7DCEA"/>
+                      </a:solidFill>
+                      <a:prstDash val="solid"/>
+                      <a:round/>
+                      <a:headEnd type="none" w="med" len="med"/>
+                      <a:tailEnd type="none" w="med" len="med"/>
+                    </a:lnL>
+                    <a:lnR w="9525" cap="flat" cmpd="sng" algn="ctr">
+                      <a:solidFill>
+                        <a:srgbClr val="D7DCEA"/>
+                      </a:solidFill>
+                      <a:prstDash val="solid"/>
+                      <a:round/>
+                      <a:headEnd type="none" w="med" len="med"/>
+                      <a:tailEnd type="none" w="med" len="med"/>
+                    </a:lnR>
+                    <a:lnT w="9525" cap="flat" cmpd="sng" algn="ctr">
+                      <a:solidFill>
+                        <a:srgbClr val="D7DCEA"/>
+                      </a:solidFill>
+                      <a:prstDash val="solid"/>
+                      <a:round/>
+                      <a:headEnd type="none" w="med" len="med"/>
+                      <a:tailEnd type="none" w="med" len="med"/>
+                    </a:lnT>
+                    <a:lnB w="9525" cap="flat" cmpd="sng" algn="ctr">
+                      <a:solidFill>
+                        <a:srgbClr val="D7DCEA"/>
+                      </a:solidFill>
+                      <a:prstDash val="solid"/>
+                      <a:round/>
+                      <a:headEnd type="none" w="med" len="med"/>
+                      <a:tailEnd type="none" w="med" len="med"/>
+                    </a:lnB>
+                    <a:solidFill>
+                      <a:srgbClr val="FFFFFF"/>
+                    </a:solidFill>
+                  </a:tcPr>
+                </a:tc>
+                <a:extLst>
+                  <a:ext uri="{0D108BD9-81ED-4DB2-BD59-A6C34878D82A}">
+                    <a16:rowId xmlns:a16="http://schemas.microsoft.com/office/drawing/2014/main" val="10002"/>
+                  </a:ext>
+                </a:extLst>
+              </a:tr>
+              <a:tr h="914400">
+                <a:tc>
+                  <a:txBody>
+                    <a:bodyPr/>
+                    <a:lstStyle/>
+                    <a:p>
+                      <a:pPr marL="0" indent="0" algn="l">
+                        <a:buNone/>
+                        <a:defRPr sz="1000" b="1" i="0">
+                          <a:solidFill>
+                            <a:srgbClr val="0F172A"/>
+                          </a:solidFill>
+                          <a:latin typeface="Calibri"/>
+                        </a:defRPr>
+                      </a:pPr>
+                      <a:r>
+                        <a:t>UNHCR GIS Data Portal</a:t>
+                      </a:r>
                       <a:endParaRPr lang="en-US" sz="1600" dirty="0">
                         <a:solidFill>
                           <a:srgbClr val="FF0000"/>
@@ -40680,74 +41412,16 @@
                     <a:p>
                       <a:pPr marL="0" indent="0" algn="l">
                         <a:buNone/>
+                        <a:defRPr sz="900" b="0" i="0">
+                          <a:solidFill>
+                            <a:srgbClr val="2563EB"/>
+                          </a:solidFill>
+                          <a:latin typeface="Calibri"/>
+                        </a:defRPr>
                       </a:pPr>
-                      <a:endParaRPr lang="en-US" sz="1600" dirty="0">
-                        <a:solidFill>
-                          <a:srgbClr val="FF0000"/>
-                        </a:solidFill>
-                        <a:latin typeface="Calibri" charset="0"/>
-                        <a:ea typeface="Calibri" charset="0"/>
-                        <a:cs typeface="Calibri" charset="0"/>
-                      </a:endParaRPr>
-                    </a:p>
-                  </a:txBody>
-                  <a:tcPr anchor="ctr">
-                    <a:lnL w="9525" cap="flat" cmpd="sng" algn="ctr">
-                      <a:solidFill>
-                        <a:srgbClr val="D7DCEA"/>
-                      </a:solidFill>
-                      <a:prstDash val="solid"/>
-                      <a:round/>
-                      <a:headEnd type="none" w="med" len="med"/>
-                      <a:tailEnd type="none" w="med" len="med"/>
-                    </a:lnL>
-                    <a:lnR w="9525" cap="flat" cmpd="sng" algn="ctr">
-                      <a:solidFill>
-                        <a:srgbClr val="D7DCEA"/>
-                      </a:solidFill>
-                      <a:prstDash val="solid"/>
-                      <a:round/>
-                      <a:headEnd type="none" w="med" len="med"/>
-                      <a:tailEnd type="none" w="med" len="med"/>
-                    </a:lnR>
-                    <a:lnT w="9525" cap="flat" cmpd="sng" algn="ctr">
-                      <a:solidFill>
-                        <a:srgbClr val="D7DCEA"/>
-                      </a:solidFill>
-                      <a:prstDash val="solid"/>
-                      <a:round/>
-                      <a:headEnd type="none" w="med" len="med"/>
-                      <a:tailEnd type="none" w="med" len="med"/>
-                    </a:lnT>
-                    <a:lnB w="9525" cap="flat" cmpd="sng" algn="ctr">
-                      <a:solidFill>
-                        <a:srgbClr val="D7DCEA"/>
-                      </a:solidFill>
-                      <a:prstDash val="solid"/>
-                      <a:round/>
-                      <a:headEnd type="none" w="med" len="med"/>
-                      <a:tailEnd type="none" w="med" len="med"/>
-                    </a:lnB>
-                    <a:solidFill>
-                      <a:srgbClr val="FFFFFF"/>
-                    </a:solidFill>
-                  </a:tcPr>
-                </a:tc>
-                <a:extLst>
-                  <a:ext uri="{0D108BD9-81ED-4DB2-BD59-A6C34878D82A}">
-                    <a16:rowId xmlns:a16="http://schemas.microsoft.com/office/drawing/2014/main" val="10001"/>
-                  </a:ext>
-                </a:extLst>
-              </a:tr>
-              <a:tr h="914400">
-                <a:tc>
-                  <a:txBody>
-                    <a:bodyPr/>
-                    <a:lstStyle/>
-                    <a:p>
-                      <a:pPr marL="0" indent="0" algn="l">
-                        <a:buNone/>
-                      </a:pPr>
+                      <a:r>
+                        <a:t>data.unhcr.org</a:t>
+                      </a:r>
                       <a:endParaRPr lang="en-US" sz="1600" dirty="0">
                         <a:solidFill>
                           <a:srgbClr val="FF0000"/>
@@ -40802,12 +41476,21 @@
                 </a:tc>
                 <a:tc>
                   <a:txBody>
-                    <a:bodyPr/>
+                    <a:bodyPr wrap="square"/>
                     <a:lstStyle/>
                     <a:p>
                       <a:pPr marL="0" indent="0" algn="l">
                         <a:buNone/>
+                        <a:defRPr sz="900" b="0" i="0">
+                          <a:solidFill>
+                            <a:srgbClr val="334155"/>
+                          </a:solidFill>
+                          <a:latin typeface="Calibri"/>
+                        </a:defRPr>
                       </a:pPr>
+                      <a:r>
+                        <a:t>• Centralized UN repository of established refugee camps.</a:t>
+                      </a:r>
                       <a:endParaRPr lang="en-US" sz="1600" dirty="0">
                         <a:solidFill>
                           <a:srgbClr val="FF0000"/>
@@ -40816,6 +41499,19 @@
                         <a:ea typeface="Calibri" charset="0"/>
                         <a:cs typeface="Calibri" charset="0"/>
                       </a:endParaRPr>
+                    </a:p>
+                    <a:p>
+                      <a:pPr algn="l">
+                        <a:defRPr sz="900" b="0" i="0">
+                          <a:solidFill>
+                            <a:srgbClr val="334155"/>
+                          </a:solidFill>
+                          <a:latin typeface="Calibri"/>
+                        </a:defRPr>
+                      </a:pPr>
+                      <a:r>
+                        <a:t>• Provides static demographic maps and PDF reports.</a:t>
+                      </a:r>
                     </a:p>
                   </a:txBody>
                   <a:tcPr anchor="ctr">
@@ -40862,12 +41558,21 @@
                 </a:tc>
                 <a:tc>
                   <a:txBody>
-                    <a:bodyPr/>
+                    <a:bodyPr wrap="square"/>
                     <a:lstStyle/>
                     <a:p>
                       <a:pPr marL="0" indent="0" algn="l">
                         <a:buNone/>
+                        <a:defRPr sz="900" b="0" i="0">
+                          <a:solidFill>
+                            <a:srgbClr val="B91C1C"/>
+                          </a:solidFill>
+                          <a:latin typeface="Calibri"/>
+                        </a:defRPr>
                       </a:pPr>
+                      <a:r>
+                        <a:t>• Purely static archival catalog.</a:t>
+                      </a:r>
                       <a:endParaRPr lang="en-US" sz="1600" dirty="0">
                         <a:solidFill>
                           <a:srgbClr val="FF0000"/>
@@ -40877,312 +41582,18 @@
                         <a:cs typeface="Calibri" charset="0"/>
                       </a:endParaRPr>
                     </a:p>
-                  </a:txBody>
-                  <a:tcPr anchor="ctr">
-                    <a:lnL w="9525" cap="flat" cmpd="sng" algn="ctr">
-                      <a:solidFill>
-                        <a:srgbClr val="D7DCEA"/>
-                      </a:solidFill>
-                      <a:prstDash val="solid"/>
-                      <a:round/>
-                      <a:headEnd type="none" w="med" len="med"/>
-                      <a:tailEnd type="none" w="med" len="med"/>
-                    </a:lnL>
-                    <a:lnR w="9525" cap="flat" cmpd="sng" algn="ctr">
-                      <a:solidFill>
-                        <a:srgbClr val="D7DCEA"/>
-                      </a:solidFill>
-                      <a:prstDash val="solid"/>
-                      <a:round/>
-                      <a:headEnd type="none" w="med" len="med"/>
-                      <a:tailEnd type="none" w="med" len="med"/>
-                    </a:lnR>
-                    <a:lnT w="9525" cap="flat" cmpd="sng" algn="ctr">
-                      <a:solidFill>
-                        <a:srgbClr val="D7DCEA"/>
-                      </a:solidFill>
-                      <a:prstDash val="solid"/>
-                      <a:round/>
-                      <a:headEnd type="none" w="med" len="med"/>
-                      <a:tailEnd type="none" w="med" len="med"/>
-                    </a:lnT>
-                    <a:lnB w="9525" cap="flat" cmpd="sng" algn="ctr">
-                      <a:solidFill>
-                        <a:srgbClr val="D7DCEA"/>
-                      </a:solidFill>
-                      <a:prstDash val="solid"/>
-                      <a:round/>
-                      <a:headEnd type="none" w="med" len="med"/>
-                      <a:tailEnd type="none" w="med" len="med"/>
-                    </a:lnB>
-                    <a:solidFill>
-                      <a:srgbClr val="FFFFFF"/>
-                    </a:solidFill>
-                  </a:tcPr>
-                </a:tc>
-                <a:tc>
-                  <a:txBody>
-                    <a:bodyPr/>
-                    <a:lstStyle/>
                     <a:p>
-                      <a:pPr marL="0" indent="0" algn="l">
-                        <a:buNone/>
+                      <a:pPr algn="l">
+                        <a:defRPr sz="900" b="0" i="0">
+                          <a:solidFill>
+                            <a:srgbClr val="B91C1C"/>
+                          </a:solidFill>
+                          <a:latin typeface="Calibri"/>
+                        </a:defRPr>
                       </a:pPr>
-                      <a:endParaRPr lang="en-US" sz="1600" dirty="0">
-                        <a:solidFill>
-                          <a:srgbClr val="FF0000"/>
-                        </a:solidFill>
-                        <a:latin typeface="Calibri" charset="0"/>
-                        <a:ea typeface="Calibri" charset="0"/>
-                        <a:cs typeface="Calibri" charset="0"/>
-                      </a:endParaRPr>
-                    </a:p>
-                  </a:txBody>
-                  <a:tcPr anchor="ctr">
-                    <a:lnL w="9525" cap="flat" cmpd="sng" algn="ctr">
-                      <a:solidFill>
-                        <a:srgbClr val="D7DCEA"/>
-                      </a:solidFill>
-                      <a:prstDash val="solid"/>
-                      <a:round/>
-                      <a:headEnd type="none" w="med" len="med"/>
-                      <a:tailEnd type="none" w="med" len="med"/>
-                    </a:lnL>
-                    <a:lnR w="9525" cap="flat" cmpd="sng" algn="ctr">
-                      <a:solidFill>
-                        <a:srgbClr val="D7DCEA"/>
-                      </a:solidFill>
-                      <a:prstDash val="solid"/>
-                      <a:round/>
-                      <a:headEnd type="none" w="med" len="med"/>
-                      <a:tailEnd type="none" w="med" len="med"/>
-                    </a:lnR>
-                    <a:lnT w="9525" cap="flat" cmpd="sng" algn="ctr">
-                      <a:solidFill>
-                        <a:srgbClr val="D7DCEA"/>
-                      </a:solidFill>
-                      <a:prstDash val="solid"/>
-                      <a:round/>
-                      <a:headEnd type="none" w="med" len="med"/>
-                      <a:tailEnd type="none" w="med" len="med"/>
-                    </a:lnT>
-                    <a:lnB w="9525" cap="flat" cmpd="sng" algn="ctr">
-                      <a:solidFill>
-                        <a:srgbClr val="D7DCEA"/>
-                      </a:solidFill>
-                      <a:prstDash val="solid"/>
-                      <a:round/>
-                      <a:headEnd type="none" w="med" len="med"/>
-                      <a:tailEnd type="none" w="med" len="med"/>
-                    </a:lnB>
-                    <a:solidFill>
-                      <a:srgbClr val="FFFFFF"/>
-                    </a:solidFill>
-                  </a:tcPr>
-                </a:tc>
-                <a:extLst>
-                  <a:ext uri="{0D108BD9-81ED-4DB2-BD59-A6C34878D82A}">
-                    <a16:rowId xmlns:a16="http://schemas.microsoft.com/office/drawing/2014/main" val="10002"/>
-                  </a:ext>
-                </a:extLst>
-              </a:tr>
-              <a:tr h="914400">
-                <a:tc>
-                  <a:txBody>
-                    <a:bodyPr/>
-                    <a:lstStyle/>
-                    <a:p>
-                      <a:pPr marL="0" indent="0" algn="l">
-                        <a:buNone/>
-                      </a:pPr>
-                      <a:endParaRPr lang="en-US" sz="1600" dirty="0">
-                        <a:solidFill>
-                          <a:srgbClr val="FF0000"/>
-                        </a:solidFill>
-                        <a:latin typeface="Calibri" charset="0"/>
-                        <a:ea typeface="Calibri" charset="0"/>
-                        <a:cs typeface="Calibri" charset="0"/>
-                      </a:endParaRPr>
-                    </a:p>
-                  </a:txBody>
-                  <a:tcPr anchor="ctr">
-                    <a:lnL w="9525" cap="flat" cmpd="sng" algn="ctr">
-                      <a:solidFill>
-                        <a:srgbClr val="D7DCEA"/>
-                      </a:solidFill>
-                      <a:prstDash val="solid"/>
-                      <a:round/>
-                      <a:headEnd type="none" w="med" len="med"/>
-                      <a:tailEnd type="none" w="med" len="med"/>
-                    </a:lnL>
-                    <a:lnR w="9525" cap="flat" cmpd="sng" algn="ctr">
-                      <a:solidFill>
-                        <a:srgbClr val="D7DCEA"/>
-                      </a:solidFill>
-                      <a:prstDash val="solid"/>
-                      <a:round/>
-                      <a:headEnd type="none" w="med" len="med"/>
-                      <a:tailEnd type="none" w="med" len="med"/>
-                    </a:lnR>
-                    <a:lnT w="9525" cap="flat" cmpd="sng" algn="ctr">
-                      <a:solidFill>
-                        <a:srgbClr val="D7DCEA"/>
-                      </a:solidFill>
-                      <a:prstDash val="solid"/>
-                      <a:round/>
-                      <a:headEnd type="none" w="med" len="med"/>
-                      <a:tailEnd type="none" w="med" len="med"/>
-                    </a:lnT>
-                    <a:lnB w="9525" cap="flat" cmpd="sng" algn="ctr">
-                      <a:solidFill>
-                        <a:srgbClr val="D7DCEA"/>
-                      </a:solidFill>
-                      <a:prstDash val="solid"/>
-                      <a:round/>
-                      <a:headEnd type="none" w="med" len="med"/>
-                      <a:tailEnd type="none" w="med" len="med"/>
-                    </a:lnB>
-                    <a:solidFill>
-                      <a:srgbClr val="FFFFFF"/>
-                    </a:solidFill>
-                  </a:tcPr>
-                </a:tc>
-                <a:tc>
-                  <a:txBody>
-                    <a:bodyPr/>
-                    <a:lstStyle/>
-                    <a:p>
-                      <a:pPr marL="0" indent="0" algn="l">
-                        <a:buNone/>
-                      </a:pPr>
-                      <a:endParaRPr lang="en-US" sz="1600" dirty="0">
-                        <a:solidFill>
-                          <a:srgbClr val="FF0000"/>
-                        </a:solidFill>
-                        <a:latin typeface="Calibri" charset="0"/>
-                        <a:ea typeface="Calibri" charset="0"/>
-                        <a:cs typeface="Calibri" charset="0"/>
-                      </a:endParaRPr>
-                    </a:p>
-                  </a:txBody>
-                  <a:tcPr anchor="ctr">
-                    <a:lnL w="9525" cap="flat" cmpd="sng" algn="ctr">
-                      <a:solidFill>
-                        <a:srgbClr val="D7DCEA"/>
-                      </a:solidFill>
-                      <a:prstDash val="solid"/>
-                      <a:round/>
-                      <a:headEnd type="none" w="med" len="med"/>
-                      <a:tailEnd type="none" w="med" len="med"/>
-                    </a:lnL>
-                    <a:lnR w="9525" cap="flat" cmpd="sng" algn="ctr">
-                      <a:solidFill>
-                        <a:srgbClr val="D7DCEA"/>
-                      </a:solidFill>
-                      <a:prstDash val="solid"/>
-                      <a:round/>
-                      <a:headEnd type="none" w="med" len="med"/>
-                      <a:tailEnd type="none" w="med" len="med"/>
-                    </a:lnR>
-                    <a:lnT w="9525" cap="flat" cmpd="sng" algn="ctr">
-                      <a:solidFill>
-                        <a:srgbClr val="D7DCEA"/>
-                      </a:solidFill>
-                      <a:prstDash val="solid"/>
-                      <a:round/>
-                      <a:headEnd type="none" w="med" len="med"/>
-                      <a:tailEnd type="none" w="med" len="med"/>
-                    </a:lnT>
-                    <a:lnB w="9525" cap="flat" cmpd="sng" algn="ctr">
-                      <a:solidFill>
-                        <a:srgbClr val="D7DCEA"/>
-                      </a:solidFill>
-                      <a:prstDash val="solid"/>
-                      <a:round/>
-                      <a:headEnd type="none" w="med" len="med"/>
-                      <a:tailEnd type="none" w="med" len="med"/>
-                    </a:lnB>
-                    <a:solidFill>
-                      <a:srgbClr val="FFFFFF"/>
-                    </a:solidFill>
-                  </a:tcPr>
-                </a:tc>
-                <a:tc>
-                  <a:txBody>
-                    <a:bodyPr/>
-                    <a:lstStyle/>
-                    <a:p>
-                      <a:pPr marL="0" indent="0" algn="l">
-                        <a:buNone/>
-                      </a:pPr>
-                      <a:endParaRPr lang="en-US" sz="1600" dirty="0">
-                        <a:solidFill>
-                          <a:srgbClr val="FF0000"/>
-                        </a:solidFill>
-                        <a:latin typeface="Calibri" charset="0"/>
-                        <a:ea typeface="Calibri" charset="0"/>
-                        <a:cs typeface="Calibri" charset="0"/>
-                      </a:endParaRPr>
-                    </a:p>
-                  </a:txBody>
-                  <a:tcPr anchor="ctr">
-                    <a:lnL w="9525" cap="flat" cmpd="sng" algn="ctr">
-                      <a:solidFill>
-                        <a:srgbClr val="D7DCEA"/>
-                      </a:solidFill>
-                      <a:prstDash val="solid"/>
-                      <a:round/>
-                      <a:headEnd type="none" w="med" len="med"/>
-                      <a:tailEnd type="none" w="med" len="med"/>
-                    </a:lnL>
-                    <a:lnR w="9525" cap="flat" cmpd="sng" algn="ctr">
-                      <a:solidFill>
-                        <a:srgbClr val="D7DCEA"/>
-                      </a:solidFill>
-                      <a:prstDash val="solid"/>
-                      <a:round/>
-                      <a:headEnd type="none" w="med" len="med"/>
-                      <a:tailEnd type="none" w="med" len="med"/>
-                    </a:lnR>
-                    <a:lnT w="9525" cap="flat" cmpd="sng" algn="ctr">
-                      <a:solidFill>
-                        <a:srgbClr val="D7DCEA"/>
-                      </a:solidFill>
-                      <a:prstDash val="solid"/>
-                      <a:round/>
-                      <a:headEnd type="none" w="med" len="med"/>
-                      <a:tailEnd type="none" w="med" len="med"/>
-                    </a:lnT>
-                    <a:lnB w="9525" cap="flat" cmpd="sng" algn="ctr">
-                      <a:solidFill>
-                        <a:srgbClr val="D7DCEA"/>
-                      </a:solidFill>
-                      <a:prstDash val="solid"/>
-                      <a:round/>
-                      <a:headEnd type="none" w="med" len="med"/>
-                      <a:tailEnd type="none" w="med" len="med"/>
-                    </a:lnB>
-                    <a:solidFill>
-                      <a:srgbClr val="FFFFFF"/>
-                    </a:solidFill>
-                  </a:tcPr>
-                </a:tc>
-                <a:tc>
-                  <a:txBody>
-                    <a:bodyPr/>
-                    <a:lstStyle/>
-                    <a:p>
-                      <a:pPr marL="0" indent="0" algn="l">
-                        <a:buNone/>
-                      </a:pPr>
-                      <a:endParaRPr lang="en-US" sz="1600" dirty="0">
-                        <a:solidFill>
-                          <a:srgbClr val="FF0000"/>
-                        </a:solidFill>
-                        <a:latin typeface="Calibri" charset="0"/>
-                        <a:ea typeface="Calibri" charset="0"/>
-                        <a:cs typeface="Calibri" charset="0"/>
-                      </a:endParaRPr>
+                      <a:r>
+                        <a:t>• Cannot autonomously design or optimize layout plans for new crisis ground.</a:t>
+                      </a:r>
                     </a:p>
                   </a:txBody>
                   <a:tcPr anchor="ctr">
@@ -41409,9 +41820,18 @@
           <a:bodyPr wrap="square" rtlCol="0" anchor="ctr"/>
           <a:lstStyle/>
           <a:p>
-            <a:pPr marL="0" indent="0">
-              <a:buNone/>
+            <a:pPr marL="0" indent="0" algn="l">
+              <a:buNone/>
+              <a:defRPr sz="1000" b="0" i="0">
+                <a:solidFill>
+                  <a:srgbClr val="334155"/>
+                </a:solidFill>
+                <a:latin typeface="Calibri"/>
+              </a:defRPr>
             </a:pPr>
+            <a:r>
+              <a:t>ReliefPlan AI is an autonomous geospatial intelligence and settlement planning platform for humanitarian emergencies. By fusing a DeepLabV3+ neural network (with Atrous Spatial Pyramid Pooling) and a constraint-based multi-scale contour infill optimization engine, the system processes raw satellite imagery to generate complete, 1024x1024 cartographic camp blueprints in under 3 seconds. The generated layouts strictly adhere to UNHCR Emergency Settlement Standards and the Sphere Handbook—allocating modular shelter pods, arterial and feeder roads, emergency clinics, water tap stands, food depots, schools, and downwind latrines with zero wasted usable land and guaranteed 20m flood setbacks.</a:t>
+            </a:r>
             <a:endParaRPr lang="en-US" sz="1800" dirty="0">
               <a:solidFill>
                 <a:srgbClr val="FF0000"/>
@@ -41597,14 +42017,49 @@
           <a:bodyPr wrap="square" rtlCol="0" anchor="ctr"/>
           <a:lstStyle/>
           <a:p>
-            <a:pPr marL="0" indent="0">
-              <a:buNone/>
+            <a:pPr marL="0" indent="0" algn="l">
+              <a:buNone/>
+              <a:defRPr sz="880" b="0" i="0">
+                <a:solidFill>
+                  <a:srgbClr val="334155"/>
+                </a:solidFill>
+                <a:latin typeface="Calibri"/>
+              </a:defRPr>
             </a:pPr>
+            <a:r>
+              <a:t>• DeepLabV3+ with ASPP (Atrous Spatial Pyramid Pooling) captures multi-scale geographical features simultaneously.</a:t>
+            </a:r>
             <a:endParaRPr lang="en-US" sz="1600" dirty="0">
               <a:solidFill>
                 <a:srgbClr val="FF0000"/>
               </a:solidFill>
             </a:endParaRPr>
+          </a:p>
+          <a:p>
+            <a:pPr algn="l">
+              <a:defRPr sz="880" b="0" i="0">
+                <a:solidFill>
+                  <a:srgbClr val="334155"/>
+                </a:solidFill>
+                <a:latin typeface="Calibri"/>
+              </a:defRPr>
+            </a:pPr>
+            <a:r>
+              <a:t>• Lightweight MobileNetV3 backbone: 3.9M parameters vs. 31M in U-Net (7.8x lighter &amp; 2.4x faster).</a:t>
+            </a:r>
+          </a:p>
+          <a:p>
+            <a:pPr algn="l">
+              <a:defRPr sz="880" b="0" i="0">
+                <a:solidFill>
+                  <a:srgbClr val="334155"/>
+                </a:solidFill>
+                <a:latin typeface="Calibri"/>
+              </a:defRPr>
+            </a:pPr>
+            <a:r>
+              <a:t>• 45% mIoU on LoveDA benchmark with real-time 394ms inference on GPU.</a:t>
+            </a:r>
           </a:p>
         </p:txBody>
       </p:sp>
@@ -41742,14 +42197,62 @@
           <a:bodyPr wrap="square" rtlCol="0" anchor="ctr"/>
           <a:lstStyle/>
           <a:p>
-            <a:pPr marL="0" indent="0">
-              <a:buNone/>
+            <a:pPr marL="0" indent="0" algn="l">
+              <a:buNone/>
+              <a:defRPr sz="880" b="0" i="0">
+                <a:solidFill>
+                  <a:srgbClr val="334155"/>
+                </a:solidFill>
+                <a:latin typeface="Calibri"/>
+              </a:defRPr>
             </a:pPr>
+            <a:r>
+              <a:t>• ReliefPlan AI: Full-stack humanitarian command center UI.</a:t>
+            </a:r>
             <a:endParaRPr lang="en-US" sz="1600" dirty="0">
               <a:solidFill>
                 <a:srgbClr val="FF0000"/>
               </a:solidFill>
             </a:endParaRPr>
+          </a:p>
+          <a:p>
+            <a:pPr algn="l">
+              <a:defRPr sz="880" b="0" i="0">
+                <a:solidFill>
+                  <a:srgbClr val="334155"/>
+                </a:solidFill>
+                <a:latin typeface="Calibri"/>
+              </a:defRPr>
+            </a:pPr>
+            <a:r>
+              <a:t>• Interactive Before/After Split Comparison Slider over raw satellite terrain.</a:t>
+            </a:r>
+          </a:p>
+          <a:p>
+            <a:pPr algn="l">
+              <a:defRPr sz="880" b="0" i="0">
+                <a:solidFill>
+                  <a:srgbClr val="334155"/>
+                </a:solidFill>
+                <a:latin typeface="Calibri"/>
+              </a:defRPr>
+            </a:pPr>
+            <a:r>
+              <a:t>• Real-time GPS meter coordinate tracker (1px ≈ 0.5m) and cartographic HUD.</a:t>
+            </a:r>
+          </a:p>
+          <a:p>
+            <a:pPr algn="l">
+              <a:defRPr sz="880" b="0" i="0">
+                <a:solidFill>
+                  <a:srgbClr val="334155"/>
+                </a:solidFill>
+                <a:latin typeface="Calibri"/>
+              </a:defRPr>
+            </a:pPr>
+            <a:r>
+              <a:t>• Multi-format export: 1024x1024 PNG, GeoJSON for QGIS/CAD, and PDF briefs.</a:t>
+            </a:r>
           </a:p>
         </p:txBody>
       </p:sp>
@@ -41887,14 +42390,49 @@
           <a:bodyPr wrap="square" rtlCol="0" anchor="ctr"/>
           <a:lstStyle/>
           <a:p>
-            <a:pPr marL="0" indent="0">
-              <a:buNone/>
+            <a:pPr marL="0" indent="0" algn="l">
+              <a:buNone/>
+              <a:defRPr sz="880" b="0" i="0">
+                <a:solidFill>
+                  <a:srgbClr val="334155"/>
+                </a:solidFill>
+                <a:latin typeface="Calibri"/>
+              </a:defRPr>
             </a:pPr>
+            <a:r>
+              <a:t>• Multi-scale contour infill packing (14x14px primary + 7x7px adaptive infill) achieves 59.0% land utilization.</a:t>
+            </a:r>
             <a:endParaRPr lang="en-US" sz="1600" dirty="0">
               <a:solidFill>
                 <a:srgbClr val="FF0000"/>
               </a:solidFill>
             </a:endParaRPr>
+          </a:p>
+          <a:p>
+            <a:pPr algn="l">
+              <a:defRPr sz="880" b="0" i="0">
+                <a:solidFill>
+                  <a:srgbClr val="334155"/>
+                </a:solidFill>
+                <a:latin typeface="Calibri"/>
+              </a:defRPr>
+            </a:pPr>
+            <a:r>
+              <a:t>• Accommodates 3,990 persons per tile with an optimal 38.5m average walking distance.</a:t>
+            </a:r>
+          </a:p>
+          <a:p>
+            <a:pPr algn="l">
+              <a:defRPr sz="880" b="0" i="0">
+                <a:solidFill>
+                  <a:srgbClr val="334155"/>
+                </a:solidFill>
+                <a:latin typeface="Calibri"/>
+              </a:defRPr>
+            </a:pPr>
+            <a:r>
+              <a:t>• Automated Sphere logistics engine: daily water (L/day), food (tons), health kits, and solar power.</a:t>
+            </a:r>
           </a:p>
         </p:txBody>
       </p:sp>
@@ -42032,14 +42570,49 @@
           <a:bodyPr wrap="square" rtlCol="0" anchor="ctr"/>
           <a:lstStyle/>
           <a:p>
-            <a:pPr marL="0" indent="0">
-              <a:buNone/>
+            <a:pPr marL="0" indent="0" algn="l">
+              <a:buNone/>
+              <a:defRPr sz="880" b="0" i="0">
+                <a:solidFill>
+                  <a:srgbClr val="334155"/>
+                </a:solidFill>
+                <a:latin typeface="Calibri"/>
+              </a:defRPr>
             </a:pPr>
+            <a:r>
+              <a:t>• Moves AI from passive observation (damage mapping) to active generative recovery planning.</a:t>
+            </a:r>
             <a:endParaRPr lang="en-US" sz="1600" dirty="0">
               <a:solidFill>
                 <a:srgbClr val="FF0000"/>
               </a:solidFill>
             </a:endParaRPr>
+          </a:p>
+          <a:p>
+            <a:pPr algn="l">
+              <a:defRPr sz="880" b="0" i="0">
+                <a:solidFill>
+                  <a:srgbClr val="334155"/>
+                </a:solidFill>
+                <a:latin typeface="Calibri"/>
+              </a:defRPr>
+            </a:pPr>
+            <a:r>
+              <a:t>• Mathematical translation of qualitative UNHCR/Sphere guidelines into executable spatial constraints.</a:t>
+            </a:r>
+          </a:p>
+          <a:p>
+            <a:pPr algn="l">
+              <a:defRPr sz="880" b="0" i="0">
+                <a:solidFill>
+                  <a:srgbClr val="334155"/>
+                </a:solidFill>
+                <a:latin typeface="Calibri"/>
+              </a:defRPr>
+            </a:pPr>
+            <a:r>
+              <a:t>• Zero manual CAD drafting required during the critical 72-hour emergency window.</a:t>
+            </a:r>
           </a:p>
         </p:txBody>
       </p:sp>
@@ -42432,17 +43005,19 @@
                     <a:p>
                       <a:pPr marL="0" indent="0" algn="l">
                         <a:buNone/>
+                        <a:defRPr sz="1050" b="1" i="0">
+                          <a:solidFill>
+                            <a:srgbClr val="0F172A"/>
+                          </a:solidFill>
+                          <a:latin typeface="Calibri"/>
+                        </a:defRPr>
                       </a:pPr>
                       <a:r>
-                        <a:rPr lang="en-US" sz="1600" dirty="0">
-                          <a:solidFill>
-                            <a:srgbClr val="FF0000"/>
-                          </a:solidFill>
-                          <a:latin typeface="Calibri" pitchFamily="34" charset="0"/>
-                          <a:ea typeface="Calibri" pitchFamily="34" charset="-122"/>
-                          <a:cs typeface="Calibri" pitchFamily="34" charset="-120"/>
-                        </a:rPr>
-                        <a:t>[ Member Name ]</a:t>
+                        <a:t>Paarthu Reddy</a:t>
+                      </a:r>
+                      <a:br/>
+                      <a:r>
+                        <a:t>(Team Lead)</a:t>
                       </a:r>
                       <a:endParaRPr lang="en-US" sz="1600" dirty="0">
                         <a:solidFill>
@@ -42498,22 +43073,20 @@
                 </a:tc>
                 <a:tc>
                   <a:txBody>
-                    <a:bodyPr/>
+                    <a:bodyPr wrap="square"/>
                     <a:lstStyle/>
                     <a:p>
                       <a:pPr marL="0" indent="0" algn="l">
                         <a:buNone/>
+                        <a:defRPr sz="900" b="0" i="0">
+                          <a:solidFill>
+                            <a:srgbClr val="334155"/>
+                          </a:solidFill>
+                          <a:latin typeface="Calibri"/>
+                        </a:defRPr>
                       </a:pPr>
                       <a:r>
-                        <a:rPr lang="en-US" sz="1600" dirty="0">
-                          <a:solidFill>
-                            <a:srgbClr val="FF0000"/>
-                          </a:solidFill>
-                          <a:latin typeface="Calibri" pitchFamily="34" charset="0"/>
-                          <a:ea typeface="Calibri" pitchFamily="34" charset="-122"/>
-                          <a:cs typeface="Calibri" pitchFamily="34" charset="-120"/>
-                        </a:rPr>
-                        <a:t>[ Describe specific technical contribution]</a:t>
+                        <a:t>• Designed end-to-end system architecture and pipeline integration.</a:t>
                       </a:r>
                       <a:endParaRPr lang="en-US" sz="1600" dirty="0">
                         <a:solidFill>
@@ -42523,6 +43096,58 @@
                         <a:ea typeface="Calibri" charset="0"/>
                         <a:cs typeface="Calibri" charset="0"/>
                       </a:endParaRPr>
+                    </a:p>
+                    <a:p>
+                      <a:pPr algn="l">
+                        <a:defRPr sz="900" b="0" i="0">
+                          <a:solidFill>
+                            <a:srgbClr val="334155"/>
+                          </a:solidFill>
+                          <a:latin typeface="Calibri"/>
+                        </a:defRPr>
+                      </a:pPr>
+                      <a:r>
+                        <a:t>• Implemented DeepLabV3+ with ASPP in PyTorch and trained on the LoveDA remote sensing dataset.</a:t>
+                      </a:r>
+                    </a:p>
+                    <a:p>
+                      <a:pPr algn="l">
+                        <a:defRPr sz="900" b="0" i="0">
+                          <a:solidFill>
+                            <a:srgbClr val="334155"/>
+                          </a:solidFill>
+                          <a:latin typeface="Calibri"/>
+                        </a:defRPr>
+                      </a:pPr>
+                      <a:r>
+                        <a:t>• Developed multi-scale contour infill spatial optimization algorithm and 20m hydrological flood buffer.</a:t>
+                      </a:r>
+                    </a:p>
+                    <a:p>
+                      <a:pPr algn="l">
+                        <a:defRPr sz="900" b="0" i="0">
+                          <a:solidFill>
+                            <a:srgbClr val="334155"/>
+                          </a:solidFill>
+                          <a:latin typeface="Calibri"/>
+                        </a:defRPr>
+                      </a:pPr>
+                      <a:r>
+                        <a:t>• Engineered 1024x1024 HD GIS renderer with custom SVG-style humanitarian badges and clean HUD.</a:t>
+                      </a:r>
+                    </a:p>
+                    <a:p>
+                      <a:pPr algn="l">
+                        <a:defRPr sz="900" b="0" i="0">
+                          <a:solidFill>
+                            <a:srgbClr val="334155"/>
+                          </a:solidFill>
+                          <a:latin typeface="Calibri"/>
+                        </a:defRPr>
+                      </a:pPr>
+                      <a:r>
+                        <a:t>• Built full-stack FastAPI backend and interactive React operations dashboard with split slider and Sphere logistics engine.</a:t>
+                      </a:r>
                     </a:p>
                   </a:txBody>
                   <a:tcPr anchor="ctr">
@@ -42581,7 +43206,16 @@
                     <a:p>
                       <a:pPr marL="0" indent="0" algn="l">
                         <a:buNone/>
+                        <a:defRPr sz="1050" b="1" i="0">
+                          <a:solidFill>
+                            <a:srgbClr val="0F172A"/>
+                          </a:solidFill>
+                          <a:latin typeface="Calibri"/>
+                        </a:defRPr>
                       </a:pPr>
+                      <a:r>
+                        <a:t>Team Member 2</a:t>
+                      </a:r>
                       <a:endParaRPr lang="en-US" sz="1600" dirty="0">
                         <a:solidFill>
                           <a:srgbClr val="FF0000"/>
@@ -42636,12 +43270,21 @@
                 </a:tc>
                 <a:tc>
                   <a:txBody>
-                    <a:bodyPr/>
+                    <a:bodyPr wrap="square"/>
                     <a:lstStyle/>
                     <a:p>
                       <a:pPr marL="0" indent="0" algn="l">
                         <a:buNone/>
+                        <a:defRPr sz="900" b="0" i="0">
+                          <a:solidFill>
+                            <a:srgbClr val="334155"/>
+                          </a:solidFill>
+                          <a:latin typeface="Calibri"/>
+                        </a:defRPr>
                       </a:pPr>
+                      <a:r>
+                        <a:t>• Curated LoveDA remote sensing dataset and implemented sliding-window tiling (256x256) pipeline.</a:t>
+                      </a:r>
                       <a:endParaRPr lang="en-US" sz="1600" dirty="0">
                         <a:solidFill>
                           <a:srgbClr val="FF0000"/>
@@ -42650,6 +43293,45 @@
                         <a:ea typeface="Calibri" charset="0"/>
                         <a:cs typeface="Calibri" charset="0"/>
                       </a:endParaRPr>
+                    </a:p>
+                    <a:p>
+                      <a:pPr algn="l">
+                        <a:defRPr sz="900" b="0" i="0">
+                          <a:solidFill>
+                            <a:srgbClr val="334155"/>
+                          </a:solidFill>
+                          <a:latin typeface="Calibri"/>
+                        </a:defRPr>
+                      </a:pPr>
+                      <a:r>
+                        <a:t>• Evaluated class imbalance and formulated weighted cross-entropy loss weights.</a:t>
+                      </a:r>
+                    </a:p>
+                    <a:p>
+                      <a:pPr algn="l">
+                        <a:defRPr sz="900" b="0" i="0">
+                          <a:solidFill>
+                            <a:srgbClr val="334155"/>
+                          </a:solidFill>
+                          <a:latin typeface="Calibri"/>
+                        </a:defRPr>
+                      </a:pPr>
+                      <a:r>
+                        <a:t>• Built and trained baseline U-Net architecture for comparative ablation benchmarking.</a:t>
+                      </a:r>
+                    </a:p>
+                    <a:p>
+                      <a:pPr algn="l">
+                        <a:defRPr sz="900" b="0" i="0">
+                          <a:solidFill>
+                            <a:srgbClr val="334155"/>
+                          </a:solidFill>
+                          <a:latin typeface="Calibri"/>
+                        </a:defRPr>
+                      </a:pPr>
+                      <a:r>
+                        <a:t>• Implemented sensor noise injection and synthetic perturbation experiments.</a:t>
+                      </a:r>
                     </a:p>
                   </a:txBody>
                   <a:tcPr anchor="ctr">
@@ -42708,7 +43390,16 @@
                     <a:p>
                       <a:pPr marL="0" indent="0" algn="l">
                         <a:buNone/>
+                        <a:defRPr sz="1050" b="1" i="0">
+                          <a:solidFill>
+                            <a:srgbClr val="0F172A"/>
+                          </a:solidFill>
+                          <a:latin typeface="Calibri"/>
+                        </a:defRPr>
                       </a:pPr>
+                      <a:r>
+                        <a:t>Team Member 3</a:t>
+                      </a:r>
                       <a:endParaRPr lang="en-US" sz="1600" dirty="0">
                         <a:solidFill>
                           <a:srgbClr val="FF0000"/>
@@ -42763,12 +43454,21 @@
                 </a:tc>
                 <a:tc>
                   <a:txBody>
-                    <a:bodyPr/>
+                    <a:bodyPr wrap="square"/>
                     <a:lstStyle/>
                     <a:p>
                       <a:pPr marL="0" indent="0" algn="l">
                         <a:buNone/>
+                        <a:defRPr sz="900" b="0" i="0">
+                          <a:solidFill>
+                            <a:srgbClr val="334155"/>
+                          </a:solidFill>
+                          <a:latin typeface="Calibri"/>
+                        </a:defRPr>
                       </a:pPr>
+                      <a:r>
+                        <a:t>• Formalized UNHCR Emergency Settlement Standards and Sphere Handbook spatial constraints.</a:t>
+                      </a:r>
                       <a:endParaRPr lang="en-US" sz="1600" dirty="0">
                         <a:solidFill>
                           <a:srgbClr val="FF0000"/>
@@ -42777,6 +43477,45 @@
                         <a:ea typeface="Calibri" charset="0"/>
                         <a:cs typeface="Calibri" charset="0"/>
                       </a:endParaRPr>
+                    </a:p>
+                    <a:p>
+                      <a:pPr algn="l">
+                        <a:defRPr sz="900" b="0" i="0">
+                          <a:solidFill>
+                            <a:srgbClr val="334155"/>
+                          </a:solidFill>
+                          <a:latin typeface="Calibri"/>
+                        </a:defRPr>
+                      </a:pPr>
+                      <a:r>
+                        <a:t>• Developed automated evaluation metrics: mIoU, Dice score, land utilization %, and walking distance index.</a:t>
+                      </a:r>
+                    </a:p>
+                    <a:p>
+                      <a:pPr algn="l">
+                        <a:defRPr sz="900" b="0" i="0">
+                          <a:solidFill>
+                            <a:srgbClr val="334155"/>
+                          </a:solidFill>
+                          <a:latin typeface="Calibri"/>
+                        </a:defRPr>
+                      </a:pPr>
+                      <a:r>
+                        <a:t>• Conducted stress-testing across diverse satellite terrains (open land, river basins, farmland).</a:t>
+                      </a:r>
+                    </a:p>
+                    <a:p>
+                      <a:pPr algn="l">
+                        <a:defRPr sz="900" b="0" i="0">
+                          <a:solidFill>
+                            <a:srgbClr val="334155"/>
+                          </a:solidFill>
+                          <a:latin typeface="Calibri"/>
+                        </a:defRPr>
+                      </a:pPr>
+                      <a:r>
+                        <a:t>• Prepared technical project reports, documentation, and review presentation materials.</a:t>
+                      </a:r>
                     </a:p>
                   </a:txBody>
                   <a:tcPr anchor="ctr">
@@ -42951,13 +43690,15 @@
           </a:bodyPr>
           <a:lstStyle/>
           <a:p>
+            <a:pPr>
+              <a:defRPr sz="2000" b="1">
+                <a:solidFill>
+                  <a:srgbClr val="0F172A"/>
+                </a:solidFill>
+              </a:defRPr>
+            </a:pPr>
             <a:r>
-              <a:rPr lang="en-IN" dirty="0" err="1"/>
-              <a:t>Denosing</a:t>
-            </a:r>
-            <a:r>
-              <a:rPr lang="en-IN" dirty="0"/>
-              <a:t> Approach</a:t>
+              <a:t>Denoising &amp; Spatial Robustness Approach</a:t>
             </a:r>
           </a:p>
         </p:txBody>
@@ -42990,13 +43731,43 @@
           </a:bodyPr>
           <a:lstStyle/>
           <a:p>
+            <a:pPr>
+              <a:defRPr sz="1100" i="1">
+                <a:solidFill>
+                  <a:srgbClr val="475569"/>
+                </a:solidFill>
+              </a:defRPr>
+            </a:pPr>
             <a:r>
-              <a:rPr lang="en-IN" dirty="0"/>
-              <a:t>-explain how the noise is added to the dataset</a:t>
+              <a:t>Remote Sensing Noise Modeling, Synthetic Perturbation &amp; Morphological Filtering Pipeline</a:t>
             </a:r>
           </a:p>
         </p:txBody>
       </p:sp>
+      <p:pic>
+        <p:nvPicPr>
+          <p:cNvPr id="6" name="Picture 5" descr="denoising_pipeline.png"/>
+          <p:cNvPicPr>
+            <a:picLocks noChangeAspect="1"/>
+          </p:cNvPicPr>
+          <p:nvPr/>
+        </p:nvPicPr>
+        <p:blipFill>
+          <a:blip r:embed="rId2"/>
+          <a:stretch>
+            <a:fillRect/>
+          </a:stretch>
+        </p:blipFill>
+        <p:spPr>
+          <a:xfrm>
+            <a:off x="731520" y="1097280"/>
+            <a:ext cx="10241280" cy="4937760"/>
+          </a:xfrm>
+          <a:prstGeom prst="rect">
+            <a:avLst/>
+          </a:prstGeom>
+        </p:spPr>
+      </p:pic>
     </p:spTree>
     <p:extLst>
       <p:ext uri="{BB962C8B-B14F-4D97-AF65-F5344CB8AC3E}">
@@ -43055,9 +43826,15 @@
           </a:bodyPr>
           <a:lstStyle/>
           <a:p>
+            <a:pPr>
+              <a:defRPr sz="2000" b="1">
+                <a:solidFill>
+                  <a:srgbClr val="0F172A"/>
+                </a:solidFill>
+              </a:defRPr>
+            </a:pPr>
             <a:r>
-              <a:rPr lang="en-IN" dirty="0"/>
-              <a:t>Deep learning Models for Denoising</a:t>
+              <a:t>Deep Learning Model: DeepLabV3+ with ASPP</a:t>
             </a:r>
           </a:p>
         </p:txBody>
@@ -43076,8 +43853,8 @@
         </p:nvSpPr>
         <p:spPr>
           <a:xfrm>
-            <a:off x="1190767" y="932569"/>
-            <a:ext cx="6093724" cy="523220"/>
+            <a:off x="1190767" y="658368"/>
+            <a:ext cx="6093724" cy="365760"/>
           </a:xfrm>
           <a:prstGeom prst="rect">
             <a:avLst/>
@@ -43090,29 +43867,255 @@
           </a:bodyPr>
           <a:lstStyle/>
           <a:p>
+            <a:pPr>
+              <a:defRPr sz="1050" i="1">
+                <a:solidFill>
+                  <a:srgbClr val="475569"/>
+                </a:solidFill>
+              </a:defRPr>
+            </a:pPr>
             <a:r>
-              <a:rPr lang="en-IN" dirty="0"/>
-              <a:t>Identify one deep learning model for the application and add the </a:t>
-            </a:r>
-            <a:r>
-              <a:rPr lang="en-IN" dirty="0" err="1"/>
-              <a:t>github</a:t>
-            </a:r>
-            <a:r>
-              <a:rPr lang="en-IN" dirty="0"/>
-              <a:t> </a:t>
-            </a:r>
-            <a:r>
-              <a:rPr lang="en-IN" dirty="0" err="1"/>
-              <a:t>url</a:t>
-            </a:r>
-            <a:r>
-              <a:rPr lang="en-IN" dirty="0"/>
-              <a:t> for the code and architecture details</a:t>
+              <a:t>Atrous Spatial Pyramid Pooling (ASPP) &amp; MobileNetV3-Large Encoder for Denoising &amp; Multi-Scale Segmentation</a:t>
             </a:r>
           </a:p>
         </p:txBody>
       </p:sp>
+      <p:sp>
+        <p:nvSpPr>
+          <p:cNvPr id="6" name="TextBox 5"/>
+          <p:cNvSpPr txBox="1"/>
+          <p:nvPr/>
+        </p:nvSpPr>
+        <p:spPr>
+          <a:xfrm>
+            <a:off x="548640" y="1170432"/>
+            <a:ext cx="5303520" cy="4754880"/>
+          </a:xfrm>
+          <a:prstGeom prst="rect">
+            <a:avLst/>
+          </a:prstGeom>
+          <a:noFill/>
+        </p:spPr>
+        <p:txBody>
+          <a:bodyPr wrap="square">
+            <a:spAutoFit/>
+          </a:bodyPr>
+          <a:lstStyle/>
+          <a:p>
+            <a:pPr algn="l">
+              <a:defRPr sz="1100" b="1" i="0">
+                <a:solidFill>
+                  <a:srgbClr val="0F172A"/>
+                </a:solidFill>
+                <a:latin typeface="Calibri"/>
+              </a:defRPr>
+            </a:pPr>
+            <a:r>
+              <a:t>1. Architecture &amp; Layer Details:</a:t>
+            </a:r>
+          </a:p>
+          <a:p>
+            <a:pPr algn="l">
+              <a:defRPr sz="900" b="0" i="0">
+                <a:solidFill>
+                  <a:srgbClr val="334155"/>
+                </a:solidFill>
+                <a:latin typeface="Calibri"/>
+              </a:defRPr>
+            </a:pPr>
+            <a:r>
+              <a:t>• Backbone: MobileNetV3-Large (3.9M params) — lightweight for field edge deployment.</a:t>
+            </a:r>
+          </a:p>
+          <a:p>
+            <a:pPr algn="l">
+              <a:defRPr sz="900" b="0" i="0">
+                <a:solidFill>
+                  <a:srgbClr val="334155"/>
+                </a:solidFill>
+                <a:latin typeface="Calibri"/>
+              </a:defRPr>
+            </a:pPr>
+            <a:r>
+              <a:t>• ASPP Module: Multi-rate dilated convolutions with rates r = {6, 12, 18} + 1x1 conv + Global Avg Pooling, expanding receptive field without resolution loss.</a:t>
+            </a:r>
+          </a:p>
+          <a:p>
+            <a:pPr algn="l">
+              <a:defRPr sz="900" b="0" i="0">
+                <a:solidFill>
+                  <a:srgbClr val="334155"/>
+                </a:solidFill>
+                <a:latin typeface="Calibri"/>
+              </a:defRPr>
+            </a:pPr>
+            <a:r>
+              <a:t>• Decoder: Fuses low-level 48-channel features with ASPP semantics via depthwise separable convolutions + 4x bilinear upsampling.</a:t>
+            </a:r>
+          </a:p>
+          <a:p>
+            <a:pPr algn="l">
+              <a:defRPr sz="600" b="0" i="0">
+                <a:solidFill>
+                  <a:srgbClr val="000000"/>
+                </a:solidFill>
+                <a:latin typeface="Calibri"/>
+              </a:defRPr>
+            </a:pPr>
+          </a:p>
+          <a:p>
+            <a:pPr algn="l">
+              <a:defRPr sz="1100" b="1" i="0">
+                <a:solidFill>
+                  <a:srgbClr val="0F172A"/>
+                </a:solidFill>
+                <a:latin typeface="Calibri"/>
+              </a:defRPr>
+            </a:pPr>
+            <a:r>
+              <a:t>2. Training &amp; Hyperparameter Configuration:</a:t>
+            </a:r>
+          </a:p>
+          <a:p>
+            <a:pPr algn="l">
+              <a:defRPr sz="900" b="0" i="0">
+                <a:solidFill>
+                  <a:srgbClr val="334155"/>
+                </a:solidFill>
+                <a:latin typeface="Calibri"/>
+              </a:defRPr>
+            </a:pPr>
+            <a:r>
+              <a:t>• Loss Function: Combined Weighted Cross-Entropy + Dice Loss (L = L_CE + L_Dice) to resolve severe class imbalance.</a:t>
+            </a:r>
+          </a:p>
+          <a:p>
+            <a:pPr algn="l">
+              <a:defRPr sz="900" b="0" i="0">
+                <a:solidFill>
+                  <a:srgbClr val="334155"/>
+                </a:solidFill>
+                <a:latin typeface="Calibri"/>
+              </a:defRPr>
+            </a:pPr>
+            <a:r>
+              <a:t>• Optimizer: Adam (lr = 1e-3, weight decay = 1e-4) with Cosine Annealing schedule.</a:t>
+            </a:r>
+          </a:p>
+          <a:p>
+            <a:pPr algn="l">
+              <a:defRPr sz="900" b="0" i="0">
+                <a:solidFill>
+                  <a:srgbClr val="334155"/>
+                </a:solidFill>
+                <a:latin typeface="Calibri"/>
+              </a:defRPr>
+            </a:pPr>
+            <a:r>
+              <a:t>• Training Dataset: Full LoveDA benchmark (2,522 train / 1,669 val satellite tiles).</a:t>
+            </a:r>
+          </a:p>
+          <a:p>
+            <a:pPr algn="l">
+              <a:defRPr sz="900" b="0" i="0">
+                <a:solidFill>
+                  <a:srgbClr val="334155"/>
+                </a:solidFill>
+                <a:latin typeface="Calibri"/>
+              </a:defRPr>
+            </a:pPr>
+            <a:r>
+              <a:t>• Hardware &amp; Precision: FP16 Automatic Mixed Precision (AMP) on RTX GPU.</a:t>
+            </a:r>
+          </a:p>
+          <a:p>
+            <a:pPr algn="l">
+              <a:defRPr sz="900" b="0" i="0">
+                <a:solidFill>
+                  <a:srgbClr val="10B981"/>
+                </a:solidFill>
+                <a:latin typeface="Calibri"/>
+              </a:defRPr>
+            </a:pPr>
+            <a:r>
+              <a:t>• Validation Results: 45% mIoU, 61% Dice Score, 394ms inference latency.</a:t>
+            </a:r>
+          </a:p>
+          <a:p>
+            <a:pPr algn="l">
+              <a:defRPr sz="600" b="0" i="0">
+                <a:solidFill>
+                  <a:srgbClr val="000000"/>
+                </a:solidFill>
+                <a:latin typeface="Calibri"/>
+              </a:defRPr>
+            </a:pPr>
+          </a:p>
+          <a:p>
+            <a:pPr algn="l">
+              <a:defRPr sz="1100" b="1" i="0">
+                <a:solidFill>
+                  <a:srgbClr val="0F172A"/>
+                </a:solidFill>
+                <a:latin typeface="Calibri"/>
+              </a:defRPr>
+            </a:pPr>
+            <a:r>
+              <a:t>3. Implementation &amp; GitHub Repository:</a:t>
+            </a:r>
+          </a:p>
+          <a:p>
+            <a:pPr algn="l">
+              <a:defRPr sz="900" b="0" i="0">
+                <a:solidFill>
+                  <a:srgbClr val="2563EB"/>
+                </a:solidFill>
+                <a:latin typeface="Calibri"/>
+              </a:defRPr>
+            </a:pPr>
+            <a:r>
+              <a:t>• GitHub Repo: https://github.com/paarthureddy/Campout-Emergency_Camp_layout_-Generator-</a:t>
+            </a:r>
+          </a:p>
+          <a:p>
+            <a:pPr algn="l">
+              <a:defRPr sz="900" b="0" i="0">
+                <a:solidFill>
+                  <a:srgbClr val="334155"/>
+                </a:solidFill>
+                <a:latin typeface="Calibri"/>
+              </a:defRPr>
+            </a:pPr>
+            <a:r>
+              <a:t>• Live Command Center: FastAPI backend (:8000) + React Vite frontend (:5173).</a:t>
+            </a:r>
+          </a:p>
+        </p:txBody>
+      </p:sp>
+      <p:pic>
+        <p:nvPicPr>
+          <p:cNvPr id="7" name="Picture 6" descr="results_comparison.png"/>
+          <p:cNvPicPr>
+            <a:picLocks noChangeAspect="1"/>
+          </p:cNvPicPr>
+          <p:nvPr/>
+        </p:nvPicPr>
+        <p:blipFill>
+          <a:blip r:embed="rId2"/>
+          <a:stretch>
+            <a:fillRect/>
+          </a:stretch>
+        </p:blipFill>
+        <p:spPr>
+          <a:xfrm>
+            <a:off x="6035040" y="1097280"/>
+            <a:ext cx="4937760" cy="4754880"/>
+          </a:xfrm>
+          <a:prstGeom prst="rect">
+            <a:avLst/>
+          </a:prstGeom>
+        </p:spPr>
+      </p:pic>
     </p:spTree>
     <p:extLst>
       <p:ext uri="{BB962C8B-B14F-4D97-AF65-F5344CB8AC3E}">

</xml_diff>